<commit_message>
Deploy preview for PR 148 🛫
</commit_message>
<xml_diff>
--- a/pr-preview/pr-148/assets/downloads/Presentation_Slides_Template.pptx
+++ b/pr-preview/pr-148/assets/downloads/Presentation_Slides_Template.pptx
@@ -128,7 +128,7 @@
 <file path=ppt/revisionInfo.xml><?xml version="1.0" encoding="utf-8"?>
 <p1510:revInfo xmlns:a="http://schemas.openxmlformats.org/drawingml/2006/main" xmlns:r="http://schemas.openxmlformats.org/officeDocument/2006/relationships" xmlns:p1510="http://schemas.microsoft.com/office/powerpoint/2015/10/main">
   <p1510:revLst>
-    <p1510:client id="{F5238676-3370-CA40-BC26-ECBBFF2095C2}" v="1" dt="2026-08-27T10:51:56.336"/>
+    <p1510:client id="{D146F594-B7FC-D246-9388-9362126610EB}" v="9" dt="2026-09-21T10:39:50.028"/>
   </p1510:revLst>
 </p1510:revInfo>
 </file>
@@ -138,16 +138,24 @@
   <pc:docChgLst>
     <pc:chgData name="Anna Helmke" userId="206455f3b88eb3a2" providerId="LiveId" clId="{C0B6E7E4-9922-5D53-B1AC-7DF53863221F}"/>
     <pc:docChg chg="undo custSel modSld modMainMaster">
-      <pc:chgData name="Anna Helmke" userId="206455f3b88eb3a2" providerId="LiveId" clId="{C0B6E7E4-9922-5D53-B1AC-7DF53863221F}" dt="2026-08-27T10:51:56.336" v="138" actId="167"/>
+      <pc:chgData name="Anna Helmke" userId="206455f3b88eb3a2" providerId="LiveId" clId="{C0B6E7E4-9922-5D53-B1AC-7DF53863221F}" dt="2026-09-21T10:40:44.422" v="280" actId="14100"/>
       <pc:docMkLst>
         <pc:docMk/>
       </pc:docMkLst>
       <pc:sldChg chg="addSp modSp mod">
-        <pc:chgData name="Anna Helmke" userId="206455f3b88eb3a2" providerId="LiveId" clId="{C0B6E7E4-9922-5D53-B1AC-7DF53863221F}" dt="2026-08-27T10:51:56.336" v="138" actId="167"/>
+        <pc:chgData name="Anna Helmke" userId="206455f3b88eb3a2" providerId="LiveId" clId="{C0B6E7E4-9922-5D53-B1AC-7DF53863221F}" dt="2026-09-21T10:23:08.862" v="180" actId="20577"/>
         <pc:sldMkLst>
           <pc:docMk/>
           <pc:sldMk cId="1707865642" sldId="298"/>
         </pc:sldMkLst>
+        <pc:spChg chg="add mod">
+          <ac:chgData name="Anna Helmke" userId="206455f3b88eb3a2" providerId="LiveId" clId="{C0B6E7E4-9922-5D53-B1AC-7DF53863221F}" dt="2026-09-21T10:23:08.862" v="180" actId="20577"/>
+          <ac:spMkLst>
+            <pc:docMk/>
+            <pc:sldMk cId="1707865642" sldId="298"/>
+            <ac:spMk id="4" creationId="{F9D4AFD1-35D7-CA58-504A-1BD6D47B2EF7}"/>
+          </ac:spMkLst>
+        </pc:spChg>
         <pc:spChg chg="mod">
           <ac:chgData name="Anna Helmke" userId="206455f3b88eb3a2" providerId="LiveId" clId="{C0B6E7E4-9922-5D53-B1AC-7DF53863221F}" dt="2026-08-27T10:51:56.336" v="138" actId="167"/>
           <ac:spMkLst>
@@ -156,37 +164,21 @@
             <ac:spMk id="22" creationId="{26F9E1B5-2502-C8B1-E4CB-B6413E27D852}"/>
           </ac:spMkLst>
         </pc:spChg>
-        <pc:spChg chg="add mod">
-          <ac:chgData name="Anna Helmke" userId="206455f3b88eb3a2" providerId="LiveId" clId="{C0B6E7E4-9922-5D53-B1AC-7DF53863221F}" dt="2026-08-27T10:51:56.336" v="138" actId="167"/>
-          <ac:spMkLst>
-            <pc:docMk/>
-            <pc:sldMk cId="1707865642" sldId="298"/>
-            <ac:spMk id="29" creationId="{E2739DBE-0BA6-3300-0CD7-6AF6A51C401E}"/>
-          </ac:spMkLst>
-        </pc:spChg>
-        <pc:picChg chg="add mod">
-          <ac:chgData name="Anna Helmke" userId="206455f3b88eb3a2" providerId="LiveId" clId="{C0B6E7E4-9922-5D53-B1AC-7DF53863221F}" dt="2026-08-27T10:51:56.336" v="138" actId="167"/>
-          <ac:picMkLst>
-            <pc:docMk/>
-            <pc:sldMk cId="1707865642" sldId="298"/>
-            <ac:picMk id="4" creationId="{1FC11308-06BD-8F8D-773A-31D823EF9A7B}"/>
-          </ac:picMkLst>
-        </pc:picChg>
-        <pc:picChg chg="add mod">
-          <ac:chgData name="Anna Helmke" userId="206455f3b88eb3a2" providerId="LiveId" clId="{C0B6E7E4-9922-5D53-B1AC-7DF53863221F}" dt="2026-08-27T10:51:00.273" v="133" actId="1076"/>
-          <ac:picMkLst>
-            <pc:docMk/>
-            <pc:sldMk cId="1707865642" sldId="298"/>
-            <ac:picMk id="23" creationId="{DFC4A1A9-2D31-1396-E73C-18C52F2C8845}"/>
-          </ac:picMkLst>
-        </pc:picChg>
       </pc:sldChg>
       <pc:sldChg chg="addSp modSp mod modTransition">
-        <pc:chgData name="Anna Helmke" userId="206455f3b88eb3a2" providerId="LiveId" clId="{C0B6E7E4-9922-5D53-B1AC-7DF53863221F}" dt="2026-08-27T10:49:30.995" v="118" actId="1038"/>
+        <pc:chgData name="Anna Helmke" userId="206455f3b88eb3a2" providerId="LiveId" clId="{C0B6E7E4-9922-5D53-B1AC-7DF53863221F}" dt="2026-09-21T10:22:32.871" v="170" actId="1038"/>
         <pc:sldMkLst>
           <pc:docMk/>
           <pc:sldMk cId="340354113" sldId="307"/>
         </pc:sldMkLst>
+        <pc:picChg chg="add mod">
+          <ac:chgData name="Anna Helmke" userId="206455f3b88eb3a2" providerId="LiveId" clId="{C0B6E7E4-9922-5D53-B1AC-7DF53863221F}" dt="2026-09-21T10:22:23.174" v="164" actId="1038"/>
+          <ac:picMkLst>
+            <pc:docMk/>
+            <pc:sldMk cId="340354113" sldId="307"/>
+            <ac:picMk id="3" creationId="{AA59B301-6A68-2D87-3402-0FCB75389035}"/>
+          </ac:picMkLst>
+        </pc:picChg>
         <pc:picChg chg="mod">
           <ac:chgData name="Anna Helmke" userId="206455f3b88eb3a2" providerId="LiveId" clId="{C0B6E7E4-9922-5D53-B1AC-7DF53863221F}" dt="2026-08-27T10:47:03.504" v="67" actId="1076"/>
           <ac:picMkLst>
@@ -196,7 +188,7 @@
           </ac:picMkLst>
         </pc:picChg>
         <pc:picChg chg="mod">
-          <ac:chgData name="Anna Helmke" userId="206455f3b88eb3a2" providerId="LiveId" clId="{C0B6E7E4-9922-5D53-B1AC-7DF53863221F}" dt="2026-08-27T10:48:45.177" v="92" actId="1035"/>
+          <ac:chgData name="Anna Helmke" userId="206455f3b88eb3a2" providerId="LiveId" clId="{C0B6E7E4-9922-5D53-B1AC-7DF53863221F}" dt="2026-09-21T10:22:23.174" v="164" actId="1038"/>
           <ac:picMkLst>
             <pc:docMk/>
             <pc:sldMk cId="340354113" sldId="307"/>
@@ -212,7 +204,7 @@
           </ac:picMkLst>
         </pc:picChg>
         <pc:picChg chg="mod">
-          <ac:chgData name="Anna Helmke" userId="206455f3b88eb3a2" providerId="LiveId" clId="{C0B6E7E4-9922-5D53-B1AC-7DF53863221F}" dt="2026-08-27T10:48:53.292" v="101" actId="1036"/>
+          <ac:chgData name="Anna Helmke" userId="206455f3b88eb3a2" providerId="LiveId" clId="{C0B6E7E4-9922-5D53-B1AC-7DF53863221F}" dt="2026-09-21T10:22:32.871" v="170" actId="1038"/>
           <ac:picMkLst>
             <pc:docMk/>
             <pc:sldMk cId="340354113" sldId="307"/>
@@ -268,7 +260,7 @@
           </ac:picMkLst>
         </pc:picChg>
         <pc:picChg chg="mod">
-          <ac:chgData name="Anna Helmke" userId="206455f3b88eb3a2" providerId="LiveId" clId="{C0B6E7E4-9922-5D53-B1AC-7DF53863221F}" dt="2026-08-27T10:48:45.177" v="92" actId="1035"/>
+          <ac:chgData name="Anna Helmke" userId="206455f3b88eb3a2" providerId="LiveId" clId="{C0B6E7E4-9922-5D53-B1AC-7DF53863221F}" dt="2026-09-21T10:22:23.174" v="164" actId="1038"/>
           <ac:picMkLst>
             <pc:docMk/>
             <pc:sldMk cId="340354113" sldId="307"/>
@@ -276,7 +268,7 @@
           </ac:picMkLst>
         </pc:picChg>
         <pc:picChg chg="mod">
-          <ac:chgData name="Anna Helmke" userId="206455f3b88eb3a2" providerId="LiveId" clId="{C0B6E7E4-9922-5D53-B1AC-7DF53863221F}" dt="2026-08-27T10:48:53.292" v="101" actId="1036"/>
+          <ac:chgData name="Anna Helmke" userId="206455f3b88eb3a2" providerId="LiveId" clId="{C0B6E7E4-9922-5D53-B1AC-7DF53863221F}" dt="2026-09-21T10:22:32.871" v="170" actId="1038"/>
           <ac:picMkLst>
             <pc:docMk/>
             <pc:sldMk cId="340354113" sldId="307"/>
@@ -284,7 +276,7 @@
           </ac:picMkLst>
         </pc:picChg>
         <pc:picChg chg="mod">
-          <ac:chgData name="Anna Helmke" userId="206455f3b88eb3a2" providerId="LiveId" clId="{C0B6E7E4-9922-5D53-B1AC-7DF53863221F}" dt="2026-08-27T10:48:45.177" v="92" actId="1035"/>
+          <ac:chgData name="Anna Helmke" userId="206455f3b88eb3a2" providerId="LiveId" clId="{C0B6E7E4-9922-5D53-B1AC-7DF53863221F}" dt="2026-09-21T10:22:23.174" v="164" actId="1038"/>
           <ac:picMkLst>
             <pc:docMk/>
             <pc:sldMk cId="340354113" sldId="307"/>
@@ -292,7 +284,7 @@
           </ac:picMkLst>
         </pc:picChg>
         <pc:picChg chg="mod">
-          <ac:chgData name="Anna Helmke" userId="206455f3b88eb3a2" providerId="LiveId" clId="{C0B6E7E4-9922-5D53-B1AC-7DF53863221F}" dt="2026-08-27T10:48:45.177" v="92" actId="1035"/>
+          <ac:chgData name="Anna Helmke" userId="206455f3b88eb3a2" providerId="LiveId" clId="{C0B6E7E4-9922-5D53-B1AC-7DF53863221F}" dt="2026-09-21T10:22:23.174" v="164" actId="1038"/>
           <ac:picMkLst>
             <pc:docMk/>
             <pc:sldMk cId="340354113" sldId="307"/>
@@ -300,7 +292,7 @@
           </ac:picMkLst>
         </pc:picChg>
         <pc:picChg chg="mod">
-          <ac:chgData name="Anna Helmke" userId="206455f3b88eb3a2" providerId="LiveId" clId="{C0B6E7E4-9922-5D53-B1AC-7DF53863221F}" dt="2026-08-27T10:48:48.121" v="98" actId="1036"/>
+          <ac:chgData name="Anna Helmke" userId="206455f3b88eb3a2" providerId="LiveId" clId="{C0B6E7E4-9922-5D53-B1AC-7DF53863221F}" dt="2026-09-21T10:22:32.871" v="170" actId="1038"/>
           <ac:picMkLst>
             <pc:docMk/>
             <pc:sldMk cId="340354113" sldId="307"/>
@@ -316,7 +308,7 @@
           </ac:picMkLst>
         </pc:picChg>
         <pc:picChg chg="mod">
-          <ac:chgData name="Anna Helmke" userId="206455f3b88eb3a2" providerId="LiveId" clId="{C0B6E7E4-9922-5D53-B1AC-7DF53863221F}" dt="2026-08-27T10:48:53.292" v="101" actId="1036"/>
+          <ac:chgData name="Anna Helmke" userId="206455f3b88eb3a2" providerId="LiveId" clId="{C0B6E7E4-9922-5D53-B1AC-7DF53863221F}" dt="2026-09-21T10:22:32.871" v="170" actId="1038"/>
           <ac:picMkLst>
             <pc:docMk/>
             <pc:sldMk cId="340354113" sldId="307"/>
@@ -324,7 +316,7 @@
           </ac:picMkLst>
         </pc:picChg>
         <pc:picChg chg="mod">
-          <ac:chgData name="Anna Helmke" userId="206455f3b88eb3a2" providerId="LiveId" clId="{C0B6E7E4-9922-5D53-B1AC-7DF53863221F}" dt="2026-08-27T10:48:53.292" v="101" actId="1036"/>
+          <ac:chgData name="Anna Helmke" userId="206455f3b88eb3a2" providerId="LiveId" clId="{C0B6E7E4-9922-5D53-B1AC-7DF53863221F}" dt="2026-09-21T10:22:32.871" v="170" actId="1038"/>
           <ac:picMkLst>
             <pc:docMk/>
             <pc:sldMk cId="340354113" sldId="307"/>
@@ -356,6 +348,189 @@
           </ac:picMkLst>
         </pc:picChg>
       </pc:sldChg>
+      <pc:sldChg chg="addSp delSp modSp mod">
+        <pc:chgData name="Anna Helmke" userId="206455f3b88eb3a2" providerId="LiveId" clId="{C0B6E7E4-9922-5D53-B1AC-7DF53863221F}" dt="2026-09-21T10:40:44.422" v="280" actId="14100"/>
+        <pc:sldMkLst>
+          <pc:docMk/>
+          <pc:sldMk cId="1264931560" sldId="326"/>
+        </pc:sldMkLst>
+        <pc:spChg chg="add mod">
+          <ac:chgData name="Anna Helmke" userId="206455f3b88eb3a2" providerId="LiveId" clId="{C0B6E7E4-9922-5D53-B1AC-7DF53863221F}" dt="2026-09-21T10:23:21.085" v="191" actId="20577"/>
+          <ac:spMkLst>
+            <pc:docMk/>
+            <pc:sldMk cId="1264931560" sldId="326"/>
+            <ac:spMk id="2" creationId="{EF6FD379-81D4-1845-888A-A6AB15D9E38E}"/>
+          </ac:spMkLst>
+        </pc:spChg>
+        <pc:spChg chg="mod">
+          <ac:chgData name="Anna Helmke" userId="206455f3b88eb3a2" providerId="LiveId" clId="{C0B6E7E4-9922-5D53-B1AC-7DF53863221F}" dt="2026-09-21T10:23:42.791" v="223" actId="1036"/>
+          <ac:spMkLst>
+            <pc:docMk/>
+            <pc:sldMk cId="1264931560" sldId="326"/>
+            <ac:spMk id="4" creationId="{AA5CE0AF-35CB-50E0-97DF-81943C30D33C}"/>
+          </ac:spMkLst>
+        </pc:spChg>
+        <pc:spChg chg="mod">
+          <ac:chgData name="Anna Helmke" userId="206455f3b88eb3a2" providerId="LiveId" clId="{C0B6E7E4-9922-5D53-B1AC-7DF53863221F}" dt="2026-09-21T10:40:44.422" v="280" actId="14100"/>
+          <ac:spMkLst>
+            <pc:docMk/>
+            <pc:sldMk cId="1264931560" sldId="326"/>
+            <ac:spMk id="5" creationId="{00792AF2-ACC7-4CB0-CA0E-E2FDD267CF4E}"/>
+          </ac:spMkLst>
+        </pc:spChg>
+        <pc:spChg chg="mod">
+          <ac:chgData name="Anna Helmke" userId="206455f3b88eb3a2" providerId="LiveId" clId="{C0B6E7E4-9922-5D53-B1AC-7DF53863221F}" dt="2026-09-21T10:38:52.995" v="255" actId="1076"/>
+          <ac:spMkLst>
+            <pc:docMk/>
+            <pc:sldMk cId="1264931560" sldId="326"/>
+            <ac:spMk id="7" creationId="{506C3CCC-F98D-24F0-BADC-24D731BA641F}"/>
+          </ac:spMkLst>
+        </pc:spChg>
+        <pc:spChg chg="mod">
+          <ac:chgData name="Anna Helmke" userId="206455f3b88eb3a2" providerId="LiveId" clId="{C0B6E7E4-9922-5D53-B1AC-7DF53863221F}" dt="2026-09-21T10:38:52.995" v="255" actId="1076"/>
+          <ac:spMkLst>
+            <pc:docMk/>
+            <pc:sldMk cId="1264931560" sldId="326"/>
+            <ac:spMk id="8" creationId="{691BE8AC-BC2F-8C62-D78F-60F57C8DA9F7}"/>
+          </ac:spMkLst>
+        </pc:spChg>
+        <pc:spChg chg="mod">
+          <ac:chgData name="Anna Helmke" userId="206455f3b88eb3a2" providerId="LiveId" clId="{C0B6E7E4-9922-5D53-B1AC-7DF53863221F}" dt="2026-09-21T10:38:52.995" v="255" actId="1076"/>
+          <ac:spMkLst>
+            <pc:docMk/>
+            <pc:sldMk cId="1264931560" sldId="326"/>
+            <ac:spMk id="9" creationId="{233B6290-A5E4-0234-827C-E79723E8C10E}"/>
+          </ac:spMkLst>
+        </pc:spChg>
+        <pc:spChg chg="mod">
+          <ac:chgData name="Anna Helmke" userId="206455f3b88eb3a2" providerId="LiveId" clId="{C0B6E7E4-9922-5D53-B1AC-7DF53863221F}" dt="2026-09-21T10:38:52.995" v="255" actId="1076"/>
+          <ac:spMkLst>
+            <pc:docMk/>
+            <pc:sldMk cId="1264931560" sldId="326"/>
+            <ac:spMk id="11" creationId="{5C5E1C97-6034-1A12-FCB2-ABCEFA5724F1}"/>
+          </ac:spMkLst>
+        </pc:spChg>
+        <pc:spChg chg="mod">
+          <ac:chgData name="Anna Helmke" userId="206455f3b88eb3a2" providerId="LiveId" clId="{C0B6E7E4-9922-5D53-B1AC-7DF53863221F}" dt="2026-09-21T10:38:52.995" v="255" actId="1076"/>
+          <ac:spMkLst>
+            <pc:docMk/>
+            <pc:sldMk cId="1264931560" sldId="326"/>
+            <ac:spMk id="13" creationId="{FB6030BE-BE73-3821-D4E6-7421CDD85D37}"/>
+          </ac:spMkLst>
+        </pc:spChg>
+        <pc:spChg chg="mod">
+          <ac:chgData name="Anna Helmke" userId="206455f3b88eb3a2" providerId="LiveId" clId="{C0B6E7E4-9922-5D53-B1AC-7DF53863221F}" dt="2026-09-21T10:38:52.995" v="255" actId="1076"/>
+          <ac:spMkLst>
+            <pc:docMk/>
+            <pc:sldMk cId="1264931560" sldId="326"/>
+            <ac:spMk id="14" creationId="{4EB9E516-F79A-4402-A437-ADB08131129C}"/>
+          </ac:spMkLst>
+        </pc:spChg>
+        <pc:spChg chg="mod">
+          <ac:chgData name="Anna Helmke" userId="206455f3b88eb3a2" providerId="LiveId" clId="{C0B6E7E4-9922-5D53-B1AC-7DF53863221F}" dt="2026-09-21T10:39:40.682" v="267" actId="166"/>
+          <ac:spMkLst>
+            <pc:docMk/>
+            <pc:sldMk cId="1264931560" sldId="326"/>
+            <ac:spMk id="16" creationId="{23B67136-3923-7A95-489B-689239F2E01C}"/>
+          </ac:spMkLst>
+        </pc:spChg>
+        <pc:spChg chg="mod">
+          <ac:chgData name="Anna Helmke" userId="206455f3b88eb3a2" providerId="LiveId" clId="{C0B6E7E4-9922-5D53-B1AC-7DF53863221F}" dt="2026-09-21T10:39:40.682" v="267" actId="166"/>
+          <ac:spMkLst>
+            <pc:docMk/>
+            <pc:sldMk cId="1264931560" sldId="326"/>
+            <ac:spMk id="18" creationId="{3509664A-8B76-2153-43F7-DF856E4FBEB0}"/>
+          </ac:spMkLst>
+        </pc:spChg>
+        <pc:spChg chg="mod">
+          <ac:chgData name="Anna Helmke" userId="206455f3b88eb3a2" providerId="LiveId" clId="{C0B6E7E4-9922-5D53-B1AC-7DF53863221F}" dt="2026-09-21T10:38:52.995" v="255" actId="1076"/>
+          <ac:spMkLst>
+            <pc:docMk/>
+            <pc:sldMk cId="1264931560" sldId="326"/>
+            <ac:spMk id="20" creationId="{F71C3435-DBF5-792E-AF95-94348728D4FC}"/>
+          </ac:spMkLst>
+        </pc:spChg>
+        <pc:spChg chg="mod">
+          <ac:chgData name="Anna Helmke" userId="206455f3b88eb3a2" providerId="LiveId" clId="{C0B6E7E4-9922-5D53-B1AC-7DF53863221F}" dt="2026-09-21T10:23:42.791" v="223" actId="1036"/>
+          <ac:spMkLst>
+            <pc:docMk/>
+            <pc:sldMk cId="1264931560" sldId="326"/>
+            <ac:spMk id="22" creationId="{C9C72C0D-EC04-F8C5-A35B-9FEEE4C943A1}"/>
+          </ac:spMkLst>
+        </pc:spChg>
+        <pc:spChg chg="mod">
+          <ac:chgData name="Anna Helmke" userId="206455f3b88eb3a2" providerId="LiveId" clId="{C0B6E7E4-9922-5D53-B1AC-7DF53863221F}" dt="2026-09-21T10:40:32.805" v="278" actId="1076"/>
+          <ac:spMkLst>
+            <pc:docMk/>
+            <pc:sldMk cId="1264931560" sldId="326"/>
+            <ac:spMk id="23" creationId="{9E36B7D1-E710-55C5-A393-D3979A81B008}"/>
+          </ac:spMkLst>
+        </pc:spChg>
+        <pc:spChg chg="mod">
+          <ac:chgData name="Anna Helmke" userId="206455f3b88eb3a2" providerId="LiveId" clId="{C0B6E7E4-9922-5D53-B1AC-7DF53863221F}" dt="2026-09-21T10:40:09.972" v="272" actId="1076"/>
+          <ac:spMkLst>
+            <pc:docMk/>
+            <pc:sldMk cId="1264931560" sldId="326"/>
+            <ac:spMk id="24" creationId="{C4B4D48F-4463-93BF-71A9-603D8E1F3572}"/>
+          </ac:spMkLst>
+        </pc:spChg>
+        <pc:spChg chg="add del mod">
+          <ac:chgData name="Anna Helmke" userId="206455f3b88eb3a2" providerId="LiveId" clId="{C0B6E7E4-9922-5D53-B1AC-7DF53863221F}" dt="2026-09-21T10:37:16.039" v="243" actId="478"/>
+          <ac:spMkLst>
+            <pc:docMk/>
+            <pc:sldMk cId="1264931560" sldId="326"/>
+            <ac:spMk id="25" creationId="{04AD3CED-0845-F91D-8255-A2503F3E641C}"/>
+          </ac:spMkLst>
+        </pc:spChg>
+        <pc:spChg chg="add mod">
+          <ac:chgData name="Anna Helmke" userId="206455f3b88eb3a2" providerId="LiveId" clId="{C0B6E7E4-9922-5D53-B1AC-7DF53863221F}" dt="2026-09-21T10:39:50.028" v="268" actId="167"/>
+          <ac:spMkLst>
+            <pc:docMk/>
+            <pc:sldMk cId="1264931560" sldId="326"/>
+            <ac:spMk id="26" creationId="{450F9970-BF84-5F24-9286-8C474C48773D}"/>
+          </ac:spMkLst>
+        </pc:spChg>
+        <pc:spChg chg="add del mod">
+          <ac:chgData name="Anna Helmke" userId="206455f3b88eb3a2" providerId="LiveId" clId="{C0B6E7E4-9922-5D53-B1AC-7DF53863221F}" dt="2026-09-21T10:39:03.248" v="262" actId="478"/>
+          <ac:spMkLst>
+            <pc:docMk/>
+            <pc:sldMk cId="1264931560" sldId="326"/>
+            <ac:spMk id="27" creationId="{9780944B-689B-DBE5-9D5A-5B2B917695ED}"/>
+          </ac:spMkLst>
+        </pc:spChg>
+        <pc:spChg chg="mod">
+          <ac:chgData name="Anna Helmke" userId="206455f3b88eb3a2" providerId="LiveId" clId="{C0B6E7E4-9922-5D53-B1AC-7DF53863221F}" dt="2026-09-21T10:39:50.028" v="268" actId="167"/>
+          <ac:spMkLst>
+            <pc:docMk/>
+            <pc:sldMk cId="1264931560" sldId="326"/>
+            <ac:spMk id="28" creationId="{FF109452-562D-591A-7E53-D24D9077C92F}"/>
+          </ac:spMkLst>
+        </pc:spChg>
+        <pc:spChg chg="mod">
+          <ac:chgData name="Anna Helmke" userId="206455f3b88eb3a2" providerId="LiveId" clId="{C0B6E7E4-9922-5D53-B1AC-7DF53863221F}" dt="2026-09-21T10:39:50.028" v="268" actId="167"/>
+          <ac:spMkLst>
+            <pc:docMk/>
+            <pc:sldMk cId="1264931560" sldId="326"/>
+            <ac:spMk id="29" creationId="{418E899A-0EC7-1A7A-BE8E-98B0D1848A21}"/>
+          </ac:spMkLst>
+        </pc:spChg>
+        <pc:spChg chg="add mod">
+          <ac:chgData name="Anna Helmke" userId="206455f3b88eb3a2" providerId="LiveId" clId="{C0B6E7E4-9922-5D53-B1AC-7DF53863221F}" dt="2026-09-21T10:39:40.682" v="267" actId="166"/>
+          <ac:spMkLst>
+            <pc:docMk/>
+            <pc:sldMk cId="1264931560" sldId="326"/>
+            <ac:spMk id="30" creationId="{63917B4C-C824-48D7-6174-C7A2E1EC0093}"/>
+          </ac:spMkLst>
+        </pc:spChg>
+        <pc:spChg chg="add mod">
+          <ac:chgData name="Anna Helmke" userId="206455f3b88eb3a2" providerId="LiveId" clId="{C0B6E7E4-9922-5D53-B1AC-7DF53863221F}" dt="2026-09-21T10:40:19.831" v="275" actId="1037"/>
+          <ac:spMkLst>
+            <pc:docMk/>
+            <pc:sldMk cId="1264931560" sldId="326"/>
+            <ac:spMk id="31" creationId="{20B839C0-6E97-35CF-4DF2-0E30DD888C65}"/>
+          </ac:spMkLst>
+        </pc:spChg>
+      </pc:sldChg>
     </pc:docChg>
   </pc:docChgLst>
 </pc:chgInfo>
@@ -443,7 +618,7 @@
           <a:p>
             <a:fld id="{B58D1FFF-3B6F-A440-B2E7-D2C34C2609DB}" type="datetimeFigureOut">
               <a:rPr lang="en-US" smtClean="0"/>
-              <a:t>9/14/26</a:t>
+              <a:t>9/21/26</a:t>
             </a:fld>
             <a:endParaRPr lang="en-US"/>
           </a:p>
@@ -2795,7 +2970,7 @@
         </p:nvSpPr>
         <p:spPr>
           <a:xfrm>
-            <a:off x="613954" y="2888649"/>
+            <a:off x="202474" y="3325385"/>
             <a:ext cx="4572698" cy="2630226"/>
           </a:xfrm>
           <a:prstGeom prst="roundRect">
@@ -2867,8 +3042,8 @@
         </p:nvSpPr>
         <p:spPr>
           <a:xfrm>
-            <a:off x="7134620" y="2891410"/>
-            <a:ext cx="4572698" cy="2878186"/>
+            <a:off x="5011732" y="3328146"/>
+            <a:ext cx="3377888" cy="2878186"/>
           </a:xfrm>
           <a:prstGeom prst="roundRect">
             <a:avLst>
@@ -2930,10 +3105,10 @@
       </p:sp>
       <p:sp>
         <p:nvSpPr>
-          <p:cNvPr id="22" name="Rounded Rectangle 21">
-            <a:extLst>
-              <a:ext uri="{FF2B5EF4-FFF2-40B4-BE49-F238E27FC236}">
-                <a16:creationId xmlns:a16="http://schemas.microsoft.com/office/drawing/2014/main" id="{C9C72C0D-EC04-F8C5-A35B-9FEEE4C943A1}"/>
+          <p:cNvPr id="26" name="Rounded Rectangle 25">
+            <a:extLst>
+              <a:ext uri="{FF2B5EF4-FFF2-40B4-BE49-F238E27FC236}">
+                <a16:creationId xmlns:a16="http://schemas.microsoft.com/office/drawing/2014/main" id="{450F9970-BF84-5F24-9286-8C474C48773D}"/>
               </a:ext>
             </a:extLst>
           </p:cNvPr>
@@ -2942,17 +3117,31 @@
         </p:nvSpPr>
         <p:spPr>
           <a:xfrm>
-            <a:off x="4289705" y="356405"/>
-            <a:ext cx="3619504" cy="1976683"/>
+            <a:off x="8608230" y="3328146"/>
+            <a:ext cx="3377888" cy="923337"/>
           </a:xfrm>
           <a:prstGeom prst="roundRect">
             <a:avLst>
-              <a:gd name="adj" fmla="val 1856"/>
+              <a:gd name="adj" fmla="val 1602"/>
             </a:avLst>
           </a:prstGeom>
-          <a:solidFill>
-            <a:srgbClr val="DDEBF8"/>
-          </a:solidFill>
+          <a:gradFill>
+            <a:gsLst>
+              <a:gs pos="86000">
+                <a:srgbClr val="DDEBF8"/>
+              </a:gs>
+              <a:gs pos="0">
+                <a:srgbClr val="DDEBF8"/>
+              </a:gs>
+              <a:gs pos="100000">
+                <a:srgbClr val="CFE3F5"/>
+              </a:gs>
+              <a:gs pos="100000">
+                <a:srgbClr val="A6CAED"/>
+              </a:gs>
+            </a:gsLst>
+            <a:lin ang="5400000" scaled="1"/>
+          </a:gradFill>
           <a:ln>
             <a:noFill/>
           </a:ln>
@@ -2991,10 +3180,10 @@
       </p:sp>
       <p:sp>
         <p:nvSpPr>
-          <p:cNvPr id="10" name="Rounded Rectangle 9">
-            <a:extLst>
-              <a:ext uri="{FF2B5EF4-FFF2-40B4-BE49-F238E27FC236}">
-                <a16:creationId xmlns:a16="http://schemas.microsoft.com/office/drawing/2014/main" id="{16F164B3-C8F9-1172-137E-DEFE9F81FEEE}"/>
+          <p:cNvPr id="22" name="Rounded Rectangle 21">
+            <a:extLst>
+              <a:ext uri="{FF2B5EF4-FFF2-40B4-BE49-F238E27FC236}">
+                <a16:creationId xmlns:a16="http://schemas.microsoft.com/office/drawing/2014/main" id="{C9C72C0D-EC04-F8C5-A35B-9FEEE4C943A1}"/>
               </a:ext>
             </a:extLst>
           </p:cNvPr>
@@ -3003,12 +3192,12 @@
         </p:nvSpPr>
         <p:spPr>
           <a:xfrm>
-            <a:off x="680280" y="5094802"/>
-            <a:ext cx="831084" cy="1116814"/>
+            <a:off x="4289705" y="793141"/>
+            <a:ext cx="3619504" cy="1976683"/>
           </a:xfrm>
           <a:prstGeom prst="roundRect">
             <a:avLst>
-              <a:gd name="adj" fmla="val 4046"/>
+              <a:gd name="adj" fmla="val 1856"/>
             </a:avLst>
           </a:prstGeom>
           <a:solidFill>
@@ -3052,10 +3241,10 @@
       </p:sp>
       <p:sp>
         <p:nvSpPr>
-          <p:cNvPr id="11" name="Rounded Rectangle 10">
-            <a:extLst>
-              <a:ext uri="{FF2B5EF4-FFF2-40B4-BE49-F238E27FC236}">
-                <a16:creationId xmlns:a16="http://schemas.microsoft.com/office/drawing/2014/main" id="{5C5E1C97-6034-1A12-FCB2-ABCEFA5724F1}"/>
+          <p:cNvPr id="10" name="Rounded Rectangle 9">
+            <a:extLst>
+              <a:ext uri="{FF2B5EF4-FFF2-40B4-BE49-F238E27FC236}">
+                <a16:creationId xmlns:a16="http://schemas.microsoft.com/office/drawing/2014/main" id="{16F164B3-C8F9-1172-137E-DEFE9F81FEEE}"/>
               </a:ext>
             </a:extLst>
           </p:cNvPr>
@@ -3064,7 +3253,7 @@
         </p:nvSpPr>
         <p:spPr>
           <a:xfrm>
-            <a:off x="1584433" y="5094801"/>
+            <a:off x="268800" y="5531538"/>
             <a:ext cx="831084" cy="1116814"/>
           </a:xfrm>
           <a:prstGeom prst="roundRect">
@@ -3113,10 +3302,10 @@
       </p:sp>
       <p:sp>
         <p:nvSpPr>
-          <p:cNvPr id="12" name="Rounded Rectangle 11">
-            <a:extLst>
-              <a:ext uri="{FF2B5EF4-FFF2-40B4-BE49-F238E27FC236}">
-                <a16:creationId xmlns:a16="http://schemas.microsoft.com/office/drawing/2014/main" id="{45A25E4C-180D-9359-8BD1-0146580E7261}"/>
+          <p:cNvPr id="11" name="Rounded Rectangle 10">
+            <a:extLst>
+              <a:ext uri="{FF2B5EF4-FFF2-40B4-BE49-F238E27FC236}">
+                <a16:creationId xmlns:a16="http://schemas.microsoft.com/office/drawing/2014/main" id="{5C5E1C97-6034-1A12-FCB2-ABCEFA5724F1}"/>
               </a:ext>
             </a:extLst>
           </p:cNvPr>
@@ -3125,7 +3314,7 @@
         </p:nvSpPr>
         <p:spPr>
           <a:xfrm>
-            <a:off x="2488586" y="5094801"/>
+            <a:off x="1172953" y="5531537"/>
             <a:ext cx="831084" cy="1116814"/>
           </a:xfrm>
           <a:prstGeom prst="roundRect">
@@ -3174,10 +3363,10 @@
       </p:sp>
       <p:sp>
         <p:nvSpPr>
-          <p:cNvPr id="13" name="Rounded Rectangle 12">
-            <a:extLst>
-              <a:ext uri="{FF2B5EF4-FFF2-40B4-BE49-F238E27FC236}">
-                <a16:creationId xmlns:a16="http://schemas.microsoft.com/office/drawing/2014/main" id="{FB6030BE-BE73-3821-D4E6-7421CDD85D37}"/>
+          <p:cNvPr id="12" name="Rounded Rectangle 11">
+            <a:extLst>
+              <a:ext uri="{FF2B5EF4-FFF2-40B4-BE49-F238E27FC236}">
+                <a16:creationId xmlns:a16="http://schemas.microsoft.com/office/drawing/2014/main" id="{45A25E4C-180D-9359-8BD1-0146580E7261}"/>
               </a:ext>
             </a:extLst>
           </p:cNvPr>
@@ -3186,7 +3375,7 @@
         </p:nvSpPr>
         <p:spPr>
           <a:xfrm>
-            <a:off x="3392739" y="5094800"/>
+            <a:off x="2077106" y="5531537"/>
             <a:ext cx="831084" cy="1116814"/>
           </a:xfrm>
           <a:prstGeom prst="roundRect">
@@ -3235,10 +3424,10 @@
       </p:sp>
       <p:sp>
         <p:nvSpPr>
-          <p:cNvPr id="14" name="Rounded Rectangle 13">
-            <a:extLst>
-              <a:ext uri="{FF2B5EF4-FFF2-40B4-BE49-F238E27FC236}">
-                <a16:creationId xmlns:a16="http://schemas.microsoft.com/office/drawing/2014/main" id="{4EB9E516-F79A-4402-A437-ADB08131129C}"/>
+          <p:cNvPr id="13" name="Rounded Rectangle 12">
+            <a:extLst>
+              <a:ext uri="{FF2B5EF4-FFF2-40B4-BE49-F238E27FC236}">
+                <a16:creationId xmlns:a16="http://schemas.microsoft.com/office/drawing/2014/main" id="{FB6030BE-BE73-3821-D4E6-7421CDD85D37}"/>
               </a:ext>
             </a:extLst>
           </p:cNvPr>
@@ -3247,7 +3436,7 @@
         </p:nvSpPr>
         <p:spPr>
           <a:xfrm>
-            <a:off x="4296892" y="5094800"/>
+            <a:off x="2981259" y="5531536"/>
             <a:ext cx="831084" cy="1116814"/>
           </a:xfrm>
           <a:prstGeom prst="roundRect">
@@ -3296,10 +3485,10 @@
       </p:sp>
       <p:sp>
         <p:nvSpPr>
-          <p:cNvPr id="15" name="Rounded Rectangle 14">
-            <a:extLst>
-              <a:ext uri="{FF2B5EF4-FFF2-40B4-BE49-F238E27FC236}">
-                <a16:creationId xmlns:a16="http://schemas.microsoft.com/office/drawing/2014/main" id="{5D5B1AA5-7E59-7738-9E29-73359B137F98}"/>
+          <p:cNvPr id="14" name="Rounded Rectangle 13">
+            <a:extLst>
+              <a:ext uri="{FF2B5EF4-FFF2-40B4-BE49-F238E27FC236}">
+                <a16:creationId xmlns:a16="http://schemas.microsoft.com/office/drawing/2014/main" id="{4EB9E516-F79A-4402-A437-ADB08131129C}"/>
               </a:ext>
             </a:extLst>
           </p:cNvPr>
@@ -3308,22 +3497,27 @@
         </p:nvSpPr>
         <p:spPr>
           <a:xfrm>
-            <a:off x="727779" y="5439812"/>
-            <a:ext cx="4348943" cy="659568"/>
+            <a:off x="3885412" y="5531536"/>
+            <a:ext cx="831084" cy="1116814"/>
           </a:xfrm>
           <a:prstGeom prst="roundRect">
             <a:avLst>
-              <a:gd name="adj" fmla="val 6003"/>
+              <a:gd name="adj" fmla="val 4046"/>
             </a:avLst>
           </a:prstGeom>
           <a:solidFill>
-            <a:srgbClr val="163E64">
-              <a:alpha val="90808"/>
-            </a:srgbClr>
+            <a:srgbClr val="DDEBF8"/>
           </a:solidFill>
           <a:ln>
             <a:noFill/>
           </a:ln>
+          <a:effectLst>
+            <a:outerShdw blurRad="50800" dist="38100" dir="2700000" algn="tl" rotWithShape="0">
+              <a:prstClr val="black">
+                <a:alpha val="40000"/>
+              </a:prstClr>
+            </a:outerShdw>
+          </a:effectLst>
         </p:spPr>
         <p:style>
           <a:lnRef idx="2">
@@ -3346,19 +3540,16 @@
           <a:lstStyle/>
           <a:p>
             <a:pPr algn="ctr"/>
-            <a:r>
-              <a:rPr lang="en-US" sz="2000" b="1" dirty="0"/>
-              <a:t>Developer Communities</a:t>
-            </a:r>
+            <a:endParaRPr lang="en-US"/>
           </a:p>
         </p:txBody>
       </p:sp>
       <p:sp>
         <p:nvSpPr>
-          <p:cNvPr id="16" name="Rounded Rectangle 15">
-            <a:extLst>
-              <a:ext uri="{FF2B5EF4-FFF2-40B4-BE49-F238E27FC236}">
-                <a16:creationId xmlns:a16="http://schemas.microsoft.com/office/drawing/2014/main" id="{23B67136-3923-7A95-489B-689239F2E01C}"/>
+          <p:cNvPr id="15" name="Rounded Rectangle 14">
+            <a:extLst>
+              <a:ext uri="{FF2B5EF4-FFF2-40B4-BE49-F238E27FC236}">
+                <a16:creationId xmlns:a16="http://schemas.microsoft.com/office/drawing/2014/main" id="{5D5B1AA5-7E59-7738-9E29-73359B137F98}"/>
               </a:ext>
             </a:extLst>
           </p:cNvPr>
@@ -3367,7 +3558,7 @@
         </p:nvSpPr>
         <p:spPr>
           <a:xfrm>
-            <a:off x="730132" y="3013502"/>
+            <a:off x="316299" y="5876548"/>
             <a:ext cx="4348943" cy="659568"/>
           </a:xfrm>
           <a:prstGeom prst="roundRect">
@@ -3376,7 +3567,9 @@
             </a:avLst>
           </a:prstGeom>
           <a:solidFill>
-            <a:srgbClr val="A6CAED"/>
+            <a:srgbClr val="163E64">
+              <a:alpha val="90808"/>
+            </a:srgbClr>
           </a:solidFill>
           <a:ln>
             <a:noFill/>
@@ -3404,22 +3597,18 @@
           <a:p>
             <a:pPr algn="ctr"/>
             <a:r>
-              <a:rPr lang="en-US" b="1" dirty="0">
-                <a:solidFill>
-                  <a:schemeClr val="tx1"/>
-                </a:solidFill>
-              </a:rPr>
-              <a:t>Technical Advisory Council (TAC)</a:t>
+              <a:rPr lang="en-US" sz="2000" b="1" dirty="0"/>
+              <a:t>Developer Communities</a:t>
             </a:r>
           </a:p>
         </p:txBody>
       </p:sp>
       <p:sp>
         <p:nvSpPr>
-          <p:cNvPr id="18" name="Rounded Rectangle 17">
-            <a:extLst>
-              <a:ext uri="{FF2B5EF4-FFF2-40B4-BE49-F238E27FC236}">
-                <a16:creationId xmlns:a16="http://schemas.microsoft.com/office/drawing/2014/main" id="{3509664A-8B76-2153-43F7-DF856E4FBEB0}"/>
+          <p:cNvPr id="4" name="Rounded Rectangle 3">
+            <a:extLst>
+              <a:ext uri="{FF2B5EF4-FFF2-40B4-BE49-F238E27FC236}">
+                <a16:creationId xmlns:a16="http://schemas.microsoft.com/office/drawing/2014/main" id="{AA5CE0AF-35CB-50E0-97DF-81943C30D33C}"/>
               </a:ext>
             </a:extLst>
           </p:cNvPr>
@@ -3428,8 +3617,8 @@
         </p:nvSpPr>
         <p:spPr>
           <a:xfrm>
-            <a:off x="7251239" y="3013502"/>
-            <a:ext cx="4348943" cy="659568"/>
+            <a:off x="4362156" y="863328"/>
+            <a:ext cx="3467687" cy="659568"/>
           </a:xfrm>
           <a:prstGeom prst="roundRect">
             <a:avLst>
@@ -3437,7 +3626,7 @@
             </a:avLst>
           </a:prstGeom>
           <a:solidFill>
-            <a:srgbClr val="A6CAED">
+            <a:srgbClr val="4F95D9">
               <a:alpha val="90808"/>
             </a:srgbClr>
           </a:solidFill>
@@ -3472,17 +3661,437 @@
                   <a:schemeClr val="tx1"/>
                 </a:solidFill>
               </a:rPr>
-              <a:t>Outreach Committee</a:t>
+              <a:t>Governing Board (GB)</a:t>
             </a:r>
           </a:p>
         </p:txBody>
       </p:sp>
       <p:sp>
         <p:nvSpPr>
-          <p:cNvPr id="4" name="Rounded Rectangle 3">
-            <a:extLst>
-              <a:ext uri="{FF2B5EF4-FFF2-40B4-BE49-F238E27FC236}">
-                <a16:creationId xmlns:a16="http://schemas.microsoft.com/office/drawing/2014/main" id="{AA5CE0AF-35CB-50E0-97DF-81943C30D33C}"/>
+          <p:cNvPr id="6" name="TextBox 5">
+            <a:extLst>
+              <a:ext uri="{FF2B5EF4-FFF2-40B4-BE49-F238E27FC236}">
+                <a16:creationId xmlns:a16="http://schemas.microsoft.com/office/drawing/2014/main" id="{98A435DD-08A4-82F9-7ADB-45DAD3524671}"/>
+              </a:ext>
+            </a:extLst>
+          </p:cNvPr>
+          <p:cNvSpPr txBox="1"/>
+          <p:nvPr/>
+        </p:nvSpPr>
+        <p:spPr>
+          <a:xfrm>
+            <a:off x="4362156" y="1541750"/>
+            <a:ext cx="3467687" cy="1200329"/>
+          </a:xfrm>
+          <a:prstGeom prst="rect">
+            <a:avLst/>
+          </a:prstGeom>
+          <a:noFill/>
+        </p:spPr>
+        <p:txBody>
+          <a:bodyPr wrap="square" rtlCol="0">
+            <a:spAutoFit/>
+          </a:bodyPr>
+          <a:lstStyle/>
+          <a:p>
+            <a:pPr marL="285750" indent="-285750">
+              <a:buFont typeface="Arial" panose="020B0604020202020204" pitchFamily="34" charset="0"/>
+              <a:buChar char="•"/>
+            </a:pPr>
+            <a:r>
+              <a:rPr lang="en-US" dirty="0"/>
+              <a:t>Strategy &amp; Priorities</a:t>
+            </a:r>
+          </a:p>
+          <a:p>
+            <a:pPr marL="285750" indent="-285750">
+              <a:buFont typeface="Arial" panose="020B0604020202020204" pitchFamily="34" charset="0"/>
+              <a:buChar char="•"/>
+            </a:pPr>
+            <a:r>
+              <a:rPr lang="en-US" dirty="0"/>
+              <a:t>Budget</a:t>
+            </a:r>
+          </a:p>
+          <a:p>
+            <a:pPr marL="285750" indent="-285750">
+              <a:buFont typeface="Arial" panose="020B0604020202020204" pitchFamily="34" charset="0"/>
+              <a:buChar char="•"/>
+            </a:pPr>
+            <a:r>
+              <a:rPr lang="en-US" dirty="0"/>
+              <a:t>Marketing Strategy &amp; Events</a:t>
+            </a:r>
+          </a:p>
+          <a:p>
+            <a:pPr marL="285750" indent="-285750">
+              <a:buFont typeface="Arial" panose="020B0604020202020204" pitchFamily="34" charset="0"/>
+              <a:buChar char="•"/>
+            </a:pPr>
+            <a:r>
+              <a:rPr lang="en-US" dirty="0"/>
+              <a:t>Legal &amp; overall governance</a:t>
+            </a:r>
+          </a:p>
+        </p:txBody>
+      </p:sp>
+      <p:sp>
+        <p:nvSpPr>
+          <p:cNvPr id="7" name="TextBox 6">
+            <a:extLst>
+              <a:ext uri="{FF2B5EF4-FFF2-40B4-BE49-F238E27FC236}">
+                <a16:creationId xmlns:a16="http://schemas.microsoft.com/office/drawing/2014/main" id="{506C3CCC-F98D-24F0-BADC-24D731BA641F}"/>
+              </a:ext>
+            </a:extLst>
+          </p:cNvPr>
+          <p:cNvSpPr txBox="1"/>
+          <p:nvPr/>
+        </p:nvSpPr>
+        <p:spPr>
+          <a:xfrm>
+            <a:off x="316299" y="4175007"/>
+            <a:ext cx="4348943" cy="1200329"/>
+          </a:xfrm>
+          <a:prstGeom prst="rect">
+            <a:avLst/>
+          </a:prstGeom>
+          <a:noFill/>
+        </p:spPr>
+        <p:txBody>
+          <a:bodyPr wrap="square" rtlCol="0">
+            <a:spAutoFit/>
+          </a:bodyPr>
+          <a:lstStyle/>
+          <a:p>
+            <a:pPr marL="285750" indent="-285750">
+              <a:buFont typeface="Arial" panose="020B0604020202020204" pitchFamily="34" charset="0"/>
+              <a:buChar char="•"/>
+            </a:pPr>
+            <a:r>
+              <a:rPr lang="en-US" dirty="0"/>
+              <a:t>Cross-project collaboration</a:t>
+            </a:r>
+          </a:p>
+          <a:p>
+            <a:pPr marL="285750" indent="-285750">
+              <a:buFont typeface="Arial" panose="020B0604020202020204" pitchFamily="34" charset="0"/>
+              <a:buChar char="•"/>
+            </a:pPr>
+            <a:r>
+              <a:rPr lang="en-US" dirty="0"/>
+              <a:t>Project Lifecycle</a:t>
+            </a:r>
+          </a:p>
+          <a:p>
+            <a:pPr marL="285750" indent="-285750">
+              <a:buFont typeface="Arial" panose="020B0604020202020204" pitchFamily="34" charset="0"/>
+              <a:buChar char="•"/>
+            </a:pPr>
+            <a:r>
+              <a:rPr lang="en-US" dirty="0"/>
+              <a:t>Management</a:t>
+            </a:r>
+          </a:p>
+          <a:p>
+            <a:pPr marL="285750" indent="-285750">
+              <a:buFont typeface="Arial" panose="020B0604020202020204" pitchFamily="34" charset="0"/>
+              <a:buChar char="•"/>
+            </a:pPr>
+            <a:r>
+              <a:rPr lang="en-US" dirty="0"/>
+              <a:t>Developer Voice to GB</a:t>
+            </a:r>
+          </a:p>
+        </p:txBody>
+      </p:sp>
+      <p:sp>
+        <p:nvSpPr>
+          <p:cNvPr id="8" name="TextBox 7">
+            <a:extLst>
+              <a:ext uri="{FF2B5EF4-FFF2-40B4-BE49-F238E27FC236}">
+                <a16:creationId xmlns:a16="http://schemas.microsoft.com/office/drawing/2014/main" id="{691BE8AC-BC2F-8C62-D78F-60F57C8DA9F7}"/>
+              </a:ext>
+            </a:extLst>
+          </p:cNvPr>
+          <p:cNvSpPr txBox="1"/>
+          <p:nvPr/>
+        </p:nvSpPr>
+        <p:spPr>
+          <a:xfrm>
+            <a:off x="5144238" y="4175007"/>
+            <a:ext cx="3119052" cy="2031325"/>
+          </a:xfrm>
+          <a:prstGeom prst="rect">
+            <a:avLst/>
+          </a:prstGeom>
+          <a:noFill/>
+        </p:spPr>
+        <p:txBody>
+          <a:bodyPr wrap="square" rtlCol="0">
+            <a:spAutoFit/>
+          </a:bodyPr>
+          <a:lstStyle/>
+          <a:p>
+            <a:pPr marL="285750" indent="-285750">
+              <a:buFont typeface="Arial" panose="020B0604020202020204" pitchFamily="34" charset="0"/>
+              <a:buChar char="•"/>
+            </a:pPr>
+            <a:r>
+              <a:rPr lang="en-US" dirty="0"/>
+              <a:t>Annual Marketing Plan</a:t>
+            </a:r>
+          </a:p>
+          <a:p>
+            <a:pPr marL="285750" indent="-285750">
+              <a:buFont typeface="Arial" panose="020B0604020202020204" pitchFamily="34" charset="0"/>
+              <a:buChar char="•"/>
+            </a:pPr>
+            <a:r>
+              <a:rPr lang="en-US" dirty="0"/>
+              <a:t>PR &amp; Social Media</a:t>
+            </a:r>
+          </a:p>
+          <a:p>
+            <a:pPr marL="285750" indent="-285750">
+              <a:buFont typeface="Arial" panose="020B0604020202020204" pitchFamily="34" charset="0"/>
+              <a:buChar char="•"/>
+            </a:pPr>
+            <a:r>
+              <a:rPr lang="en-US" dirty="0"/>
+              <a:t>Events</a:t>
+            </a:r>
+          </a:p>
+          <a:p>
+            <a:pPr marL="285750" indent="-285750">
+              <a:buFont typeface="Arial" panose="020B0604020202020204" pitchFamily="34" charset="0"/>
+              <a:buChar char="•"/>
+            </a:pPr>
+            <a:r>
+              <a:rPr lang="en-US" dirty="0"/>
+              <a:t>Content/Web</a:t>
+            </a:r>
+          </a:p>
+          <a:p>
+            <a:pPr marL="285750" indent="-285750">
+              <a:buFont typeface="Arial" panose="020B0604020202020204" pitchFamily="34" charset="0"/>
+              <a:buChar char="•"/>
+            </a:pPr>
+            <a:r>
+              <a:rPr lang="en-US" dirty="0"/>
+              <a:t>Branding</a:t>
+            </a:r>
+          </a:p>
+          <a:p>
+            <a:pPr marL="285750" indent="-285750">
+              <a:buFont typeface="Arial" panose="020B0604020202020204" pitchFamily="34" charset="0"/>
+              <a:buChar char="•"/>
+            </a:pPr>
+            <a:r>
+              <a:rPr lang="en-US" dirty="0"/>
+              <a:t>Market Development</a:t>
+            </a:r>
+          </a:p>
+          <a:p>
+            <a:pPr marL="285750" indent="-285750">
+              <a:buFont typeface="Arial" panose="020B0604020202020204" pitchFamily="34" charset="0"/>
+              <a:buChar char="•"/>
+            </a:pPr>
+            <a:r>
+              <a:rPr lang="en-US" dirty="0"/>
+              <a:t>Ambassadors</a:t>
+            </a:r>
+          </a:p>
+        </p:txBody>
+      </p:sp>
+      <p:sp>
+        <p:nvSpPr>
+          <p:cNvPr id="9" name="TextBox 8">
+            <a:extLst>
+              <a:ext uri="{FF2B5EF4-FFF2-40B4-BE49-F238E27FC236}">
+                <a16:creationId xmlns:a16="http://schemas.microsoft.com/office/drawing/2014/main" id="{233B6290-A5E4-0234-827C-E79723E8C10E}"/>
+              </a:ext>
+            </a:extLst>
+          </p:cNvPr>
+          <p:cNvSpPr txBox="1"/>
+          <p:nvPr/>
+        </p:nvSpPr>
+        <p:spPr>
+          <a:xfrm>
+            <a:off x="268800" y="5561926"/>
+            <a:ext cx="831084" cy="276999"/>
+          </a:xfrm>
+          <a:prstGeom prst="rect">
+            <a:avLst/>
+          </a:prstGeom>
+          <a:noFill/>
+        </p:spPr>
+        <p:txBody>
+          <a:bodyPr wrap="square" rtlCol="0">
+            <a:spAutoFit/>
+          </a:bodyPr>
+          <a:lstStyle/>
+          <a:p>
+            <a:pPr algn="ctr"/>
+            <a:r>
+              <a:rPr lang="en-US" sz="1200" dirty="0"/>
+              <a:t>Gardener</a:t>
+            </a:r>
+          </a:p>
+        </p:txBody>
+      </p:sp>
+      <p:sp>
+        <p:nvSpPr>
+          <p:cNvPr id="17" name="TextBox 16">
+            <a:extLst>
+              <a:ext uri="{FF2B5EF4-FFF2-40B4-BE49-F238E27FC236}">
+                <a16:creationId xmlns:a16="http://schemas.microsoft.com/office/drawing/2014/main" id="{BFA922A8-FFCD-091B-F1AD-3F7BD826FBCA}"/>
+              </a:ext>
+            </a:extLst>
+          </p:cNvPr>
+          <p:cNvSpPr txBox="1"/>
+          <p:nvPr/>
+        </p:nvSpPr>
+        <p:spPr>
+          <a:xfrm>
+            <a:off x="1172183" y="5561926"/>
+            <a:ext cx="831084" cy="276999"/>
+          </a:xfrm>
+          <a:prstGeom prst="rect">
+            <a:avLst/>
+          </a:prstGeom>
+          <a:noFill/>
+        </p:spPr>
+        <p:txBody>
+          <a:bodyPr wrap="square" rtlCol="0">
+            <a:spAutoFit/>
+          </a:bodyPr>
+          <a:lstStyle/>
+          <a:p>
+            <a:pPr algn="ctr"/>
+            <a:r>
+              <a:rPr lang="en-US" sz="1200" dirty="0" err="1"/>
+              <a:t>IronCore</a:t>
+            </a:r>
+            <a:endParaRPr lang="en-US" sz="1200" dirty="0"/>
+          </a:p>
+        </p:txBody>
+      </p:sp>
+      <p:sp>
+        <p:nvSpPr>
+          <p:cNvPr id="19" name="TextBox 18">
+            <a:extLst>
+              <a:ext uri="{FF2B5EF4-FFF2-40B4-BE49-F238E27FC236}">
+                <a16:creationId xmlns:a16="http://schemas.microsoft.com/office/drawing/2014/main" id="{00AD1526-7530-BA07-06EB-2E8C6978A088}"/>
+              </a:ext>
+            </a:extLst>
+          </p:cNvPr>
+          <p:cNvSpPr txBox="1"/>
+          <p:nvPr/>
+        </p:nvSpPr>
+        <p:spPr>
+          <a:xfrm>
+            <a:off x="2075566" y="5561926"/>
+            <a:ext cx="831084" cy="276999"/>
+          </a:xfrm>
+          <a:prstGeom prst="rect">
+            <a:avLst/>
+          </a:prstGeom>
+          <a:noFill/>
+        </p:spPr>
+        <p:txBody>
+          <a:bodyPr wrap="square" rtlCol="0">
+            <a:spAutoFit/>
+          </a:bodyPr>
+          <a:lstStyle/>
+          <a:p>
+            <a:pPr algn="ctr"/>
+            <a:r>
+              <a:rPr lang="en-US" sz="1200" dirty="0" err="1"/>
+              <a:t>Katalis</a:t>
+            </a:r>
+            <a:endParaRPr lang="en-US" sz="1200" dirty="0"/>
+          </a:p>
+        </p:txBody>
+      </p:sp>
+      <p:sp>
+        <p:nvSpPr>
+          <p:cNvPr id="20" name="TextBox 19">
+            <a:extLst>
+              <a:ext uri="{FF2B5EF4-FFF2-40B4-BE49-F238E27FC236}">
+                <a16:creationId xmlns:a16="http://schemas.microsoft.com/office/drawing/2014/main" id="{F71C3435-DBF5-792E-AF95-94348728D4FC}"/>
+              </a:ext>
+            </a:extLst>
+          </p:cNvPr>
+          <p:cNvSpPr txBox="1"/>
+          <p:nvPr/>
+        </p:nvSpPr>
+        <p:spPr>
+          <a:xfrm>
+            <a:off x="2945898" y="5561926"/>
+            <a:ext cx="904110" cy="276999"/>
+          </a:xfrm>
+          <a:prstGeom prst="rect">
+            <a:avLst/>
+          </a:prstGeom>
+          <a:noFill/>
+        </p:spPr>
+        <p:txBody>
+          <a:bodyPr wrap="square" rtlCol="0">
+            <a:spAutoFit/>
+          </a:bodyPr>
+          <a:lstStyle/>
+          <a:p>
+            <a:pPr algn="ctr"/>
+            <a:r>
+              <a:rPr lang="en-US" sz="1200" dirty="0" err="1"/>
+              <a:t>CobalCore</a:t>
+            </a:r>
+            <a:endParaRPr lang="en-US" sz="1200" dirty="0"/>
+          </a:p>
+        </p:txBody>
+      </p:sp>
+      <p:sp>
+        <p:nvSpPr>
+          <p:cNvPr id="21" name="TextBox 20">
+            <a:extLst>
+              <a:ext uri="{FF2B5EF4-FFF2-40B4-BE49-F238E27FC236}">
+                <a16:creationId xmlns:a16="http://schemas.microsoft.com/office/drawing/2014/main" id="{9EDC215D-4D32-F7EE-99B5-FE8A47048C3E}"/>
+              </a:ext>
+            </a:extLst>
+          </p:cNvPr>
+          <p:cNvSpPr txBox="1"/>
+          <p:nvPr/>
+        </p:nvSpPr>
+        <p:spPr>
+          <a:xfrm>
+            <a:off x="3882332" y="5561926"/>
+            <a:ext cx="831084" cy="276999"/>
+          </a:xfrm>
+          <a:prstGeom prst="rect">
+            <a:avLst/>
+          </a:prstGeom>
+          <a:noFill/>
+        </p:spPr>
+        <p:txBody>
+          <a:bodyPr wrap="square" rtlCol="0">
+            <a:spAutoFit/>
+          </a:bodyPr>
+          <a:lstStyle/>
+          <a:p>
+            <a:pPr algn="ctr"/>
+            <a:r>
+              <a:rPr lang="en-US" sz="1200" dirty="0"/>
+              <a:t>etc.</a:t>
+            </a:r>
+          </a:p>
+        </p:txBody>
+      </p:sp>
+      <p:sp>
+        <p:nvSpPr>
+          <p:cNvPr id="3" name="Shape 4">
+            <a:extLst>
+              <a:ext uri="{FF2B5EF4-FFF2-40B4-BE49-F238E27FC236}">
+                <a16:creationId xmlns:a16="http://schemas.microsoft.com/office/drawing/2014/main" id="{F3C0E0C3-6479-E65C-043E-C86B05613932}"/>
               </a:ext>
             </a:extLst>
           </p:cNvPr>
@@ -3491,8 +4100,193 @@
         </p:nvSpPr>
         <p:spPr>
           <a:xfrm>
-            <a:off x="4362156" y="426592"/>
-            <a:ext cx="3467687" cy="659568"/>
+            <a:off x="6102355" y="2773714"/>
+            <a:ext cx="0" cy="365760"/>
+          </a:xfrm>
+          <a:prstGeom prst="line">
+            <a:avLst/>
+          </a:prstGeom>
+          <a:noFill/>
+          <a:ln w="25400">
+            <a:solidFill>
+              <a:srgbClr val="163E64"/>
+            </a:solidFill>
+            <a:prstDash val="solid"/>
+          </a:ln>
+        </p:spPr>
+        <p:txBody>
+          <a:bodyPr/>
+          <a:lstStyle/>
+          <a:p>
+            <a:endParaRPr lang="de-DE"/>
+          </a:p>
+        </p:txBody>
+      </p:sp>
+      <p:sp>
+        <p:nvSpPr>
+          <p:cNvPr id="5" name="Shape 5">
+            <a:extLst>
+              <a:ext uri="{FF2B5EF4-FFF2-40B4-BE49-F238E27FC236}">
+                <a16:creationId xmlns:a16="http://schemas.microsoft.com/office/drawing/2014/main" id="{00792AF2-ACC7-4CB0-CA0E-E2FDD267CF4E}"/>
+              </a:ext>
+            </a:extLst>
+          </p:cNvPr>
+          <p:cNvSpPr/>
+          <p:nvPr/>
+        </p:nvSpPr>
+        <p:spPr>
+          <a:xfrm flipV="1">
+            <a:off x="2478534" y="3148070"/>
+            <a:ext cx="7824865" cy="0"/>
+          </a:xfrm>
+          <a:prstGeom prst="line">
+            <a:avLst/>
+          </a:prstGeom>
+          <a:noFill/>
+          <a:ln w="25400">
+            <a:solidFill>
+              <a:srgbClr val="163E64"/>
+            </a:solidFill>
+            <a:prstDash val="solid"/>
+          </a:ln>
+        </p:spPr>
+        <p:txBody>
+          <a:bodyPr/>
+          <a:lstStyle/>
+          <a:p>
+            <a:endParaRPr lang="de-DE"/>
+          </a:p>
+        </p:txBody>
+      </p:sp>
+      <p:sp>
+        <p:nvSpPr>
+          <p:cNvPr id="2" name="TextBox 1">
+            <a:extLst>
+              <a:ext uri="{FF2B5EF4-FFF2-40B4-BE49-F238E27FC236}">
+                <a16:creationId xmlns:a16="http://schemas.microsoft.com/office/drawing/2014/main" id="{EF6FD379-81D4-1845-888A-A6AB15D9E38E}"/>
+              </a:ext>
+            </a:extLst>
+          </p:cNvPr>
+          <p:cNvSpPr txBox="1"/>
+          <p:nvPr/>
+        </p:nvSpPr>
+        <p:spPr>
+          <a:xfrm>
+            <a:off x="4361863" y="317206"/>
+            <a:ext cx="3468273" cy="400110"/>
+          </a:xfrm>
+          <a:prstGeom prst="rect">
+            <a:avLst/>
+          </a:prstGeom>
+          <a:noFill/>
+        </p:spPr>
+        <p:txBody>
+          <a:bodyPr wrap="square">
+            <a:spAutoFit/>
+          </a:bodyPr>
+          <a:lstStyle/>
+          <a:p>
+            <a:pPr algn="ctr">
+              <a:buNone/>
+            </a:pPr>
+            <a:r>
+              <a:rPr lang="en-US" sz="2000" b="1" dirty="0">
+                <a:effectLst/>
+                <a:latin typeface="Aptos" panose="020B0004020202020204" pitchFamily="34" charset="0"/>
+              </a:rPr>
+              <a:t>Governance</a:t>
+            </a:r>
+          </a:p>
+        </p:txBody>
+      </p:sp>
+      <p:sp>
+        <p:nvSpPr>
+          <p:cNvPr id="23" name="Shape 6">
+            <a:extLst>
+              <a:ext uri="{FF2B5EF4-FFF2-40B4-BE49-F238E27FC236}">
+                <a16:creationId xmlns:a16="http://schemas.microsoft.com/office/drawing/2014/main" id="{9E36B7D1-E710-55C5-A393-D3979A81B008}"/>
+              </a:ext>
+            </a:extLst>
+          </p:cNvPr>
+          <p:cNvSpPr/>
+          <p:nvPr/>
+        </p:nvSpPr>
+        <p:spPr>
+          <a:xfrm>
+            <a:off x="2478534" y="3139474"/>
+            <a:ext cx="0" cy="320040"/>
+          </a:xfrm>
+          <a:prstGeom prst="line">
+            <a:avLst/>
+          </a:prstGeom>
+          <a:noFill/>
+          <a:ln w="25400">
+            <a:solidFill>
+              <a:srgbClr val="163E64"/>
+            </a:solidFill>
+            <a:prstDash val="solid"/>
+          </a:ln>
+        </p:spPr>
+        <p:txBody>
+          <a:bodyPr/>
+          <a:lstStyle/>
+          <a:p>
+            <a:endParaRPr lang="de-DE"/>
+          </a:p>
+        </p:txBody>
+      </p:sp>
+      <p:sp>
+        <p:nvSpPr>
+          <p:cNvPr id="24" name="Shape 8">
+            <a:extLst>
+              <a:ext uri="{FF2B5EF4-FFF2-40B4-BE49-F238E27FC236}">
+                <a16:creationId xmlns:a16="http://schemas.microsoft.com/office/drawing/2014/main" id="{C4B4D48F-4463-93BF-71A9-603D8E1F3572}"/>
+              </a:ext>
+            </a:extLst>
+          </p:cNvPr>
+          <p:cNvSpPr/>
+          <p:nvPr/>
+        </p:nvSpPr>
+        <p:spPr>
+          <a:xfrm>
+            <a:off x="6699269" y="3148070"/>
+            <a:ext cx="0" cy="311444"/>
+          </a:xfrm>
+          <a:prstGeom prst="line">
+            <a:avLst/>
+          </a:prstGeom>
+          <a:noFill/>
+          <a:ln w="25400">
+            <a:solidFill>
+              <a:srgbClr val="163E64"/>
+            </a:solidFill>
+            <a:prstDash val="solid"/>
+          </a:ln>
+        </p:spPr>
+        <p:txBody>
+          <a:bodyPr/>
+          <a:lstStyle/>
+          <a:p>
+            <a:endParaRPr lang="de-DE"/>
+          </a:p>
+        </p:txBody>
+      </p:sp>
+      <p:sp>
+        <p:nvSpPr>
+          <p:cNvPr id="16" name="Rounded Rectangle 15">
+            <a:extLst>
+              <a:ext uri="{FF2B5EF4-FFF2-40B4-BE49-F238E27FC236}">
+                <a16:creationId xmlns:a16="http://schemas.microsoft.com/office/drawing/2014/main" id="{23B67136-3923-7A95-489B-689239F2E01C}"/>
+              </a:ext>
+            </a:extLst>
+          </p:cNvPr>
+          <p:cNvSpPr/>
+          <p:nvPr/>
+        </p:nvSpPr>
+        <p:spPr>
+          <a:xfrm>
+            <a:off x="318652" y="3450238"/>
+            <a:ext cx="4348943" cy="659568"/>
           </a:xfrm>
           <a:prstGeom prst="roundRect">
             <a:avLst>
@@ -3500,9 +4294,7 @@
             </a:avLst>
           </a:prstGeom>
           <a:solidFill>
-            <a:srgbClr val="4F95D9">
-              <a:alpha val="90808"/>
-            </a:srgbClr>
+            <a:srgbClr val="A6CAED"/>
           </a:solidFill>
           <a:ln>
             <a:noFill/>
@@ -3535,437 +4327,143 @@
                   <a:schemeClr val="tx1"/>
                 </a:solidFill>
               </a:rPr>
-              <a:t>Governing Board (GB)</a:t>
+              <a:t>Technical Advisory Council (TAC)</a:t>
             </a:r>
           </a:p>
         </p:txBody>
       </p:sp>
       <p:sp>
         <p:nvSpPr>
-          <p:cNvPr id="6" name="TextBox 5">
-            <a:extLst>
-              <a:ext uri="{FF2B5EF4-FFF2-40B4-BE49-F238E27FC236}">
-                <a16:creationId xmlns:a16="http://schemas.microsoft.com/office/drawing/2014/main" id="{98A435DD-08A4-82F9-7ADB-45DAD3524671}"/>
-              </a:ext>
-            </a:extLst>
-          </p:cNvPr>
-          <p:cNvSpPr txBox="1"/>
-          <p:nvPr/>
-        </p:nvSpPr>
-        <p:spPr>
-          <a:xfrm>
-            <a:off x="4362156" y="1105014"/>
-            <a:ext cx="3467687" cy="1200329"/>
-          </a:xfrm>
-          <a:prstGeom prst="rect">
-            <a:avLst/>
-          </a:prstGeom>
-          <a:noFill/>
-        </p:spPr>
+          <p:cNvPr id="18" name="Rounded Rectangle 17">
+            <a:extLst>
+              <a:ext uri="{FF2B5EF4-FFF2-40B4-BE49-F238E27FC236}">
+                <a16:creationId xmlns:a16="http://schemas.microsoft.com/office/drawing/2014/main" id="{3509664A-8B76-2153-43F7-DF856E4FBEB0}"/>
+              </a:ext>
+            </a:extLst>
+          </p:cNvPr>
+          <p:cNvSpPr/>
+          <p:nvPr/>
+        </p:nvSpPr>
+        <p:spPr>
+          <a:xfrm>
+            <a:off x="5144238" y="3450238"/>
+            <a:ext cx="3119052" cy="659568"/>
+          </a:xfrm>
+          <a:prstGeom prst="roundRect">
+            <a:avLst>
+              <a:gd name="adj" fmla="val 6003"/>
+            </a:avLst>
+          </a:prstGeom>
+          <a:solidFill>
+            <a:srgbClr val="A6CAED">
+              <a:alpha val="90808"/>
+            </a:srgbClr>
+          </a:solidFill>
+          <a:ln>
+            <a:noFill/>
+          </a:ln>
+        </p:spPr>
+        <p:style>
+          <a:lnRef idx="2">
+            <a:schemeClr val="accent1">
+              <a:shade val="15000"/>
+            </a:schemeClr>
+          </a:lnRef>
+          <a:fillRef idx="1">
+            <a:schemeClr val="accent1"/>
+          </a:fillRef>
+          <a:effectRef idx="0">
+            <a:schemeClr val="accent1"/>
+          </a:effectRef>
+          <a:fontRef idx="minor">
+            <a:schemeClr val="lt1"/>
+          </a:fontRef>
+        </p:style>
         <p:txBody>
-          <a:bodyPr wrap="square" rtlCol="0">
-            <a:spAutoFit/>
-          </a:bodyPr>
-          <a:lstStyle/>
-          <a:p>
-            <a:pPr marL="285750" indent="-285750">
-              <a:buFont typeface="Arial" panose="020B0604020202020204" pitchFamily="34" charset="0"/>
-              <a:buChar char="•"/>
-            </a:pPr>
-            <a:r>
-              <a:rPr lang="en-US" dirty="0"/>
-              <a:t>Strategy &amp; Priorities</a:t>
-            </a:r>
-          </a:p>
-          <a:p>
-            <a:pPr marL="285750" indent="-285750">
-              <a:buFont typeface="Arial" panose="020B0604020202020204" pitchFamily="34" charset="0"/>
-              <a:buChar char="•"/>
-            </a:pPr>
-            <a:r>
-              <a:rPr lang="en-US" dirty="0"/>
-              <a:t>Budget</a:t>
-            </a:r>
-          </a:p>
-          <a:p>
-            <a:pPr marL="285750" indent="-285750">
-              <a:buFont typeface="Arial" panose="020B0604020202020204" pitchFamily="34" charset="0"/>
-              <a:buChar char="•"/>
-            </a:pPr>
-            <a:r>
-              <a:rPr lang="en-US" dirty="0"/>
-              <a:t>Marketing Strategy &amp; Events</a:t>
-            </a:r>
-          </a:p>
-          <a:p>
-            <a:pPr marL="285750" indent="-285750">
-              <a:buFont typeface="Arial" panose="020B0604020202020204" pitchFamily="34" charset="0"/>
-              <a:buChar char="•"/>
-            </a:pPr>
-            <a:r>
-              <a:rPr lang="en-US" dirty="0"/>
-              <a:t>Legal &amp; overall governance</a:t>
-            </a:r>
-          </a:p>
-        </p:txBody>
-      </p:sp>
-      <p:sp>
-        <p:nvSpPr>
-          <p:cNvPr id="7" name="TextBox 6">
-            <a:extLst>
-              <a:ext uri="{FF2B5EF4-FFF2-40B4-BE49-F238E27FC236}">
-                <a16:creationId xmlns:a16="http://schemas.microsoft.com/office/drawing/2014/main" id="{506C3CCC-F98D-24F0-BADC-24D731BA641F}"/>
-              </a:ext>
-            </a:extLst>
-          </p:cNvPr>
-          <p:cNvSpPr txBox="1"/>
-          <p:nvPr/>
-        </p:nvSpPr>
-        <p:spPr>
-          <a:xfrm>
-            <a:off x="727779" y="3738271"/>
-            <a:ext cx="4348943" cy="1200329"/>
-          </a:xfrm>
-          <a:prstGeom prst="rect">
-            <a:avLst/>
-          </a:prstGeom>
-          <a:noFill/>
-        </p:spPr>
-        <p:txBody>
-          <a:bodyPr wrap="square" rtlCol="0">
-            <a:spAutoFit/>
-          </a:bodyPr>
-          <a:lstStyle/>
-          <a:p>
-            <a:pPr marL="285750" indent="-285750">
-              <a:buFont typeface="Arial" panose="020B0604020202020204" pitchFamily="34" charset="0"/>
-              <a:buChar char="•"/>
-            </a:pPr>
-            <a:r>
-              <a:rPr lang="en-US" dirty="0"/>
-              <a:t>Cross-project collaboration</a:t>
-            </a:r>
-          </a:p>
-          <a:p>
-            <a:pPr marL="285750" indent="-285750">
-              <a:buFont typeface="Arial" panose="020B0604020202020204" pitchFamily="34" charset="0"/>
-              <a:buChar char="•"/>
-            </a:pPr>
-            <a:r>
-              <a:rPr lang="en-US" dirty="0"/>
-              <a:t>Project Lifecycle</a:t>
-            </a:r>
-          </a:p>
-          <a:p>
-            <a:pPr marL="285750" indent="-285750">
-              <a:buFont typeface="Arial" panose="020B0604020202020204" pitchFamily="34" charset="0"/>
-              <a:buChar char="•"/>
-            </a:pPr>
-            <a:r>
-              <a:rPr lang="en-US" dirty="0"/>
-              <a:t>Management</a:t>
-            </a:r>
-          </a:p>
-          <a:p>
-            <a:pPr marL="285750" indent="-285750">
-              <a:buFont typeface="Arial" panose="020B0604020202020204" pitchFamily="34" charset="0"/>
-              <a:buChar char="•"/>
-            </a:pPr>
-            <a:r>
-              <a:rPr lang="en-US" dirty="0"/>
-              <a:t>Developer Voice to GB</a:t>
-            </a:r>
-          </a:p>
-        </p:txBody>
-      </p:sp>
-      <p:sp>
-        <p:nvSpPr>
-          <p:cNvPr id="8" name="TextBox 7">
-            <a:extLst>
-              <a:ext uri="{FF2B5EF4-FFF2-40B4-BE49-F238E27FC236}">
-                <a16:creationId xmlns:a16="http://schemas.microsoft.com/office/drawing/2014/main" id="{691BE8AC-BC2F-8C62-D78F-60F57C8DA9F7}"/>
-              </a:ext>
-            </a:extLst>
-          </p:cNvPr>
-          <p:cNvSpPr txBox="1"/>
-          <p:nvPr/>
-        </p:nvSpPr>
-        <p:spPr>
-          <a:xfrm>
-            <a:off x="7271866" y="3738271"/>
-            <a:ext cx="4348943" cy="2031325"/>
-          </a:xfrm>
-          <a:prstGeom prst="rect">
-            <a:avLst/>
-          </a:prstGeom>
-          <a:noFill/>
-        </p:spPr>
-        <p:txBody>
-          <a:bodyPr wrap="square" rtlCol="0">
-            <a:spAutoFit/>
-          </a:bodyPr>
-          <a:lstStyle/>
-          <a:p>
-            <a:pPr marL="285750" indent="-285750">
-              <a:buFont typeface="Arial" panose="020B0604020202020204" pitchFamily="34" charset="0"/>
-              <a:buChar char="•"/>
-            </a:pPr>
-            <a:r>
-              <a:rPr lang="en-US" dirty="0"/>
-              <a:t>Annual Marketing Plan</a:t>
-            </a:r>
-          </a:p>
-          <a:p>
-            <a:pPr marL="285750" indent="-285750">
-              <a:buFont typeface="Arial" panose="020B0604020202020204" pitchFamily="34" charset="0"/>
-              <a:buChar char="•"/>
-            </a:pPr>
-            <a:r>
-              <a:rPr lang="en-US" dirty="0"/>
-              <a:t>PR &amp; Social Media</a:t>
-            </a:r>
-          </a:p>
-          <a:p>
-            <a:pPr marL="285750" indent="-285750">
-              <a:buFont typeface="Arial" panose="020B0604020202020204" pitchFamily="34" charset="0"/>
-              <a:buChar char="•"/>
-            </a:pPr>
-            <a:r>
-              <a:rPr lang="en-US" dirty="0"/>
-              <a:t>Events</a:t>
-            </a:r>
-          </a:p>
-          <a:p>
-            <a:pPr marL="285750" indent="-285750">
-              <a:buFont typeface="Arial" panose="020B0604020202020204" pitchFamily="34" charset="0"/>
-              <a:buChar char="•"/>
-            </a:pPr>
-            <a:r>
-              <a:rPr lang="en-US" dirty="0"/>
-              <a:t>Content/Web</a:t>
-            </a:r>
-          </a:p>
-          <a:p>
-            <a:pPr marL="285750" indent="-285750">
-              <a:buFont typeface="Arial" panose="020B0604020202020204" pitchFamily="34" charset="0"/>
-              <a:buChar char="•"/>
-            </a:pPr>
-            <a:r>
-              <a:rPr lang="en-US" dirty="0"/>
-              <a:t>Branding</a:t>
-            </a:r>
-          </a:p>
-          <a:p>
-            <a:pPr marL="285750" indent="-285750">
-              <a:buFont typeface="Arial" panose="020B0604020202020204" pitchFamily="34" charset="0"/>
-              <a:buChar char="•"/>
-            </a:pPr>
-            <a:r>
-              <a:rPr lang="en-US" dirty="0"/>
-              <a:t>Market Development</a:t>
-            </a:r>
-          </a:p>
-          <a:p>
-            <a:pPr marL="285750" indent="-285750">
-              <a:buFont typeface="Arial" panose="020B0604020202020204" pitchFamily="34" charset="0"/>
-              <a:buChar char="•"/>
-            </a:pPr>
-            <a:r>
-              <a:rPr lang="en-US" dirty="0"/>
-              <a:t>Ambassadors</a:t>
-            </a:r>
-          </a:p>
-        </p:txBody>
-      </p:sp>
-      <p:sp>
-        <p:nvSpPr>
-          <p:cNvPr id="9" name="TextBox 8">
-            <a:extLst>
-              <a:ext uri="{FF2B5EF4-FFF2-40B4-BE49-F238E27FC236}">
-                <a16:creationId xmlns:a16="http://schemas.microsoft.com/office/drawing/2014/main" id="{233B6290-A5E4-0234-827C-E79723E8C10E}"/>
-              </a:ext>
-            </a:extLst>
-          </p:cNvPr>
-          <p:cNvSpPr txBox="1"/>
-          <p:nvPr/>
-        </p:nvSpPr>
-        <p:spPr>
-          <a:xfrm>
-            <a:off x="680280" y="5125190"/>
-            <a:ext cx="831084" cy="276999"/>
-          </a:xfrm>
-          <a:prstGeom prst="rect">
-            <a:avLst/>
-          </a:prstGeom>
-          <a:noFill/>
-        </p:spPr>
-        <p:txBody>
-          <a:bodyPr wrap="square" rtlCol="0">
-            <a:spAutoFit/>
-          </a:bodyPr>
+          <a:bodyPr rtlCol="0" anchor="ctr"/>
           <a:lstStyle/>
           <a:p>
             <a:pPr algn="ctr"/>
             <a:r>
-              <a:rPr lang="en-US" sz="1200" dirty="0"/>
-              <a:t>Gardener</a:t>
+              <a:rPr lang="en-US" b="1" dirty="0">
+                <a:solidFill>
+                  <a:schemeClr val="tx1"/>
+                </a:solidFill>
+              </a:rPr>
+              <a:t>Outreach Committee</a:t>
             </a:r>
           </a:p>
         </p:txBody>
       </p:sp>
       <p:sp>
         <p:nvSpPr>
-          <p:cNvPr id="17" name="TextBox 16">
-            <a:extLst>
-              <a:ext uri="{FF2B5EF4-FFF2-40B4-BE49-F238E27FC236}">
-                <a16:creationId xmlns:a16="http://schemas.microsoft.com/office/drawing/2014/main" id="{BFA922A8-FFCD-091B-F1AD-3F7BD826FBCA}"/>
-              </a:ext>
-            </a:extLst>
-          </p:cNvPr>
-          <p:cNvSpPr txBox="1"/>
-          <p:nvPr/>
-        </p:nvSpPr>
-        <p:spPr>
-          <a:xfrm>
-            <a:off x="1583663" y="5125190"/>
-            <a:ext cx="831084" cy="276999"/>
-          </a:xfrm>
-          <a:prstGeom prst="rect">
-            <a:avLst/>
-          </a:prstGeom>
-          <a:noFill/>
-        </p:spPr>
+          <p:cNvPr id="30" name="Rounded Rectangle 29">
+            <a:extLst>
+              <a:ext uri="{FF2B5EF4-FFF2-40B4-BE49-F238E27FC236}">
+                <a16:creationId xmlns:a16="http://schemas.microsoft.com/office/drawing/2014/main" id="{63917B4C-C824-48D7-6174-C7A2E1EC0093}"/>
+              </a:ext>
+            </a:extLst>
+          </p:cNvPr>
+          <p:cNvSpPr/>
+          <p:nvPr/>
+        </p:nvSpPr>
+        <p:spPr>
+          <a:xfrm>
+            <a:off x="8740736" y="3450238"/>
+            <a:ext cx="3119052" cy="659568"/>
+          </a:xfrm>
+          <a:prstGeom prst="roundRect">
+            <a:avLst>
+              <a:gd name="adj" fmla="val 6003"/>
+            </a:avLst>
+          </a:prstGeom>
+          <a:solidFill>
+            <a:srgbClr val="A6CAED">
+              <a:alpha val="90808"/>
+            </a:srgbClr>
+          </a:solidFill>
+          <a:ln>
+            <a:noFill/>
+          </a:ln>
+        </p:spPr>
+        <p:style>
+          <a:lnRef idx="2">
+            <a:schemeClr val="accent1">
+              <a:shade val="15000"/>
+            </a:schemeClr>
+          </a:lnRef>
+          <a:fillRef idx="1">
+            <a:schemeClr val="accent1"/>
+          </a:fillRef>
+          <a:effectRef idx="0">
+            <a:schemeClr val="accent1"/>
+          </a:effectRef>
+          <a:fontRef idx="minor">
+            <a:schemeClr val="lt1"/>
+          </a:fontRef>
+        </p:style>
         <p:txBody>
-          <a:bodyPr wrap="square" rtlCol="0">
-            <a:spAutoFit/>
-          </a:bodyPr>
+          <a:bodyPr rtlCol="0" anchor="ctr"/>
           <a:lstStyle/>
           <a:p>
             <a:pPr algn="ctr"/>
             <a:r>
-              <a:rPr lang="en-US" sz="1200" dirty="0" err="1"/>
-              <a:t>IronCore</a:t>
+              <a:rPr lang="en-US" b="1" dirty="0">
+                <a:solidFill>
+                  <a:schemeClr val="tx1"/>
+                </a:solidFill>
+              </a:rPr>
+              <a:t>Other Committees</a:t>
             </a:r>
-            <a:endParaRPr lang="en-US" sz="1200" dirty="0"/>
           </a:p>
         </p:txBody>
       </p:sp>
       <p:sp>
         <p:nvSpPr>
-          <p:cNvPr id="19" name="TextBox 18">
-            <a:extLst>
-              <a:ext uri="{FF2B5EF4-FFF2-40B4-BE49-F238E27FC236}">
-                <a16:creationId xmlns:a16="http://schemas.microsoft.com/office/drawing/2014/main" id="{00AD1526-7530-BA07-06EB-2E8C6978A088}"/>
-              </a:ext>
-            </a:extLst>
-          </p:cNvPr>
-          <p:cNvSpPr txBox="1"/>
-          <p:nvPr/>
-        </p:nvSpPr>
-        <p:spPr>
-          <a:xfrm>
-            <a:off x="2487046" y="5125190"/>
-            <a:ext cx="831084" cy="276999"/>
-          </a:xfrm>
-          <a:prstGeom prst="rect">
-            <a:avLst/>
-          </a:prstGeom>
-          <a:noFill/>
-        </p:spPr>
-        <p:txBody>
-          <a:bodyPr wrap="square" rtlCol="0">
-            <a:spAutoFit/>
-          </a:bodyPr>
-          <a:lstStyle/>
-          <a:p>
-            <a:pPr algn="ctr"/>
-            <a:r>
-              <a:rPr lang="en-US" sz="1200" dirty="0" err="1"/>
-              <a:t>Katalis</a:t>
-            </a:r>
-            <a:endParaRPr lang="en-US" sz="1200" dirty="0"/>
-          </a:p>
-        </p:txBody>
-      </p:sp>
-      <p:sp>
-        <p:nvSpPr>
-          <p:cNvPr id="20" name="TextBox 19">
-            <a:extLst>
-              <a:ext uri="{FF2B5EF4-FFF2-40B4-BE49-F238E27FC236}">
-                <a16:creationId xmlns:a16="http://schemas.microsoft.com/office/drawing/2014/main" id="{F71C3435-DBF5-792E-AF95-94348728D4FC}"/>
-              </a:ext>
-            </a:extLst>
-          </p:cNvPr>
-          <p:cNvSpPr txBox="1"/>
-          <p:nvPr/>
-        </p:nvSpPr>
-        <p:spPr>
-          <a:xfrm>
-            <a:off x="3357378" y="5125190"/>
-            <a:ext cx="904110" cy="276999"/>
-          </a:xfrm>
-          <a:prstGeom prst="rect">
-            <a:avLst/>
-          </a:prstGeom>
-          <a:noFill/>
-        </p:spPr>
-        <p:txBody>
-          <a:bodyPr wrap="square" rtlCol="0">
-            <a:spAutoFit/>
-          </a:bodyPr>
-          <a:lstStyle/>
-          <a:p>
-            <a:pPr algn="ctr"/>
-            <a:r>
-              <a:rPr lang="en-US" sz="1200" dirty="0" err="1"/>
-              <a:t>CobalCore</a:t>
-            </a:r>
-            <a:endParaRPr lang="en-US" sz="1200" dirty="0"/>
-          </a:p>
-        </p:txBody>
-      </p:sp>
-      <p:sp>
-        <p:nvSpPr>
-          <p:cNvPr id="21" name="TextBox 20">
-            <a:extLst>
-              <a:ext uri="{FF2B5EF4-FFF2-40B4-BE49-F238E27FC236}">
-                <a16:creationId xmlns:a16="http://schemas.microsoft.com/office/drawing/2014/main" id="{9EDC215D-4D32-F7EE-99B5-FE8A47048C3E}"/>
-              </a:ext>
-            </a:extLst>
-          </p:cNvPr>
-          <p:cNvSpPr txBox="1"/>
-          <p:nvPr/>
-        </p:nvSpPr>
-        <p:spPr>
-          <a:xfrm>
-            <a:off x="4293812" y="5125190"/>
-            <a:ext cx="831084" cy="276999"/>
-          </a:xfrm>
-          <a:prstGeom prst="rect">
-            <a:avLst/>
-          </a:prstGeom>
-          <a:noFill/>
-        </p:spPr>
-        <p:txBody>
-          <a:bodyPr wrap="square" rtlCol="0">
-            <a:spAutoFit/>
-          </a:bodyPr>
-          <a:lstStyle/>
-          <a:p>
-            <a:pPr algn="ctr"/>
-            <a:r>
-              <a:rPr lang="en-US" sz="1200" dirty="0"/>
-              <a:t>etc.</a:t>
-            </a:r>
-          </a:p>
-        </p:txBody>
-      </p:sp>
-      <p:sp>
-        <p:nvSpPr>
-          <p:cNvPr id="3" name="Shape 4">
-            <a:extLst>
-              <a:ext uri="{FF2B5EF4-FFF2-40B4-BE49-F238E27FC236}">
-                <a16:creationId xmlns:a16="http://schemas.microsoft.com/office/drawing/2014/main" id="{F3C0E0C3-6479-E65C-043E-C86B05613932}"/>
+          <p:cNvPr id="31" name="Shape 8">
+            <a:extLst>
+              <a:ext uri="{FF2B5EF4-FFF2-40B4-BE49-F238E27FC236}">
+                <a16:creationId xmlns:a16="http://schemas.microsoft.com/office/drawing/2014/main" id="{20B839C0-6E97-35CF-4DF2-0E30DD888C65}"/>
               </a:ext>
             </a:extLst>
           </p:cNvPr>
@@ -3974,116 +4472,8 @@
         </p:nvSpPr>
         <p:spPr>
           <a:xfrm>
-            <a:off x="6102355" y="2336978"/>
-            <a:ext cx="0" cy="365760"/>
-          </a:xfrm>
-          <a:prstGeom prst="line">
-            <a:avLst/>
-          </a:prstGeom>
-          <a:noFill/>
-          <a:ln w="25400">
-            <a:solidFill>
-              <a:srgbClr val="163E64"/>
-            </a:solidFill>
-            <a:prstDash val="solid"/>
-          </a:ln>
-        </p:spPr>
-        <p:txBody>
-          <a:bodyPr/>
-          <a:lstStyle/>
-          <a:p>
-            <a:endParaRPr lang="de-DE"/>
-          </a:p>
-        </p:txBody>
-      </p:sp>
-      <p:sp>
-        <p:nvSpPr>
-          <p:cNvPr id="5" name="Shape 5">
-            <a:extLst>
-              <a:ext uri="{FF2B5EF4-FFF2-40B4-BE49-F238E27FC236}">
-                <a16:creationId xmlns:a16="http://schemas.microsoft.com/office/drawing/2014/main" id="{00792AF2-ACC7-4CB0-CA0E-E2FDD267CF4E}"/>
-              </a:ext>
-            </a:extLst>
-          </p:cNvPr>
-          <p:cNvSpPr/>
-          <p:nvPr/>
-        </p:nvSpPr>
-        <p:spPr>
-          <a:xfrm flipV="1">
-            <a:off x="3072134" y="2711334"/>
-            <a:ext cx="6047731" cy="0"/>
-          </a:xfrm>
-          <a:prstGeom prst="line">
-            <a:avLst/>
-          </a:prstGeom>
-          <a:noFill/>
-          <a:ln w="25400">
-            <a:solidFill>
-              <a:srgbClr val="163E64"/>
-            </a:solidFill>
-            <a:prstDash val="solid"/>
-          </a:ln>
-        </p:spPr>
-        <p:txBody>
-          <a:bodyPr/>
-          <a:lstStyle/>
-          <a:p>
-            <a:endParaRPr lang="de-DE"/>
-          </a:p>
-        </p:txBody>
-      </p:sp>
-      <p:sp>
-        <p:nvSpPr>
-          <p:cNvPr id="23" name="Shape 6">
-            <a:extLst>
-              <a:ext uri="{FF2B5EF4-FFF2-40B4-BE49-F238E27FC236}">
-                <a16:creationId xmlns:a16="http://schemas.microsoft.com/office/drawing/2014/main" id="{9E36B7D1-E710-55C5-A393-D3979A81B008}"/>
-              </a:ext>
-            </a:extLst>
-          </p:cNvPr>
-          <p:cNvSpPr/>
-          <p:nvPr/>
-        </p:nvSpPr>
-        <p:spPr>
-          <a:xfrm>
-            <a:off x="3084835" y="2702738"/>
-            <a:ext cx="0" cy="320040"/>
-          </a:xfrm>
-          <a:prstGeom prst="line">
-            <a:avLst/>
-          </a:prstGeom>
-          <a:noFill/>
-          <a:ln w="25400">
-            <a:solidFill>
-              <a:srgbClr val="163E64"/>
-            </a:solidFill>
-            <a:prstDash val="solid"/>
-          </a:ln>
-        </p:spPr>
-        <p:txBody>
-          <a:bodyPr/>
-          <a:lstStyle/>
-          <a:p>
-            <a:endParaRPr lang="de-DE"/>
-          </a:p>
-        </p:txBody>
-      </p:sp>
-      <p:sp>
-        <p:nvSpPr>
-          <p:cNvPr id="24" name="Shape 8">
-            <a:extLst>
-              <a:ext uri="{FF2B5EF4-FFF2-40B4-BE49-F238E27FC236}">
-                <a16:creationId xmlns:a16="http://schemas.microsoft.com/office/drawing/2014/main" id="{C4B4D48F-4463-93BF-71A9-603D8E1F3572}"/>
-              </a:ext>
-            </a:extLst>
-          </p:cNvPr>
-          <p:cNvSpPr/>
-          <p:nvPr/>
-        </p:nvSpPr>
-        <p:spPr>
-          <a:xfrm>
-            <a:off x="9119875" y="2696949"/>
-            <a:ext cx="0" cy="325830"/>
+            <a:off x="10303399" y="3148070"/>
+            <a:ext cx="0" cy="311444"/>
           </a:xfrm>
           <a:prstGeom prst="line">
             <a:avLst/>
@@ -9248,6 +9638,47 @@
           </a:prstGeom>
         </p:spPr>
       </p:pic>
+      <p:sp>
+        <p:nvSpPr>
+          <p:cNvPr id="4" name="TextBox 3">
+            <a:extLst>
+              <a:ext uri="{FF2B5EF4-FFF2-40B4-BE49-F238E27FC236}">
+                <a16:creationId xmlns:a16="http://schemas.microsoft.com/office/drawing/2014/main" id="{F9D4AFD1-35D7-CA58-504A-1BD6D47B2EF7}"/>
+              </a:ext>
+            </a:extLst>
+          </p:cNvPr>
+          <p:cNvSpPr txBox="1"/>
+          <p:nvPr/>
+        </p:nvSpPr>
+        <p:spPr>
+          <a:xfrm>
+            <a:off x="4361863" y="317206"/>
+            <a:ext cx="3468273" cy="400110"/>
+          </a:xfrm>
+          <a:prstGeom prst="rect">
+            <a:avLst/>
+          </a:prstGeom>
+          <a:noFill/>
+        </p:spPr>
+        <p:txBody>
+          <a:bodyPr wrap="square">
+            <a:spAutoFit/>
+          </a:bodyPr>
+          <a:lstStyle/>
+          <a:p>
+            <a:pPr algn="ctr">
+              <a:buNone/>
+            </a:pPr>
+            <a:r>
+              <a:rPr lang="en-US" sz="2000" b="1" dirty="0">
+                <a:effectLst/>
+                <a:latin typeface="Aptos" panose="020B0004020202020204" pitchFamily="34" charset="0"/>
+              </a:rPr>
+              <a:t>Projects</a:t>
+            </a:r>
+          </a:p>
+        </p:txBody>
+      </p:sp>
     </p:spTree>
     <p:extLst>
       <p:ext uri="{BB962C8B-B14F-4D97-AF65-F5344CB8AC3E}">
@@ -9981,7 +10412,7 @@
         </p:blipFill>
         <p:spPr>
           <a:xfrm>
-            <a:off x="1281214" y="4072383"/>
+            <a:off x="1335806" y="4072383"/>
             <a:ext cx="1516963" cy="362641"/>
           </a:xfrm>
           <a:prstGeom prst="rect">
@@ -10010,7 +10441,7 @@
         </p:blipFill>
         <p:spPr>
           <a:xfrm>
-            <a:off x="7158014" y="4691352"/>
+            <a:off x="8371713" y="4691352"/>
             <a:ext cx="1344239" cy="422736"/>
           </a:xfrm>
           <a:prstGeom prst="rect">
@@ -10039,7 +10470,7 @@
         </p:blipFill>
         <p:spPr>
           <a:xfrm>
-            <a:off x="7150143" y="4033258"/>
+            <a:off x="7204735" y="4033258"/>
             <a:ext cx="1298831" cy="409156"/>
           </a:xfrm>
           <a:prstGeom prst="rect">
@@ -10068,7 +10499,7 @@
         </p:blipFill>
         <p:spPr>
           <a:xfrm>
-            <a:off x="5267882" y="4096342"/>
+            <a:off x="5322474" y="4096342"/>
             <a:ext cx="1549180" cy="334822"/>
           </a:xfrm>
           <a:prstGeom prst="rect">
@@ -10097,7 +10528,7 @@
         </p:blipFill>
         <p:spPr>
           <a:xfrm>
-            <a:off x="8970310" y="3913726"/>
+            <a:off x="1788351" y="4637405"/>
             <a:ext cx="1329805" cy="600404"/>
           </a:xfrm>
           <a:prstGeom prst="rect">
@@ -10155,7 +10586,7 @@
         </p:blipFill>
         <p:spPr>
           <a:xfrm>
-            <a:off x="4414403" y="4777564"/>
+            <a:off x="5628102" y="4777564"/>
             <a:ext cx="1329805" cy="305362"/>
           </a:xfrm>
           <a:prstGeom prst="rect">
@@ -10184,7 +10615,7 @@
         </p:blipFill>
         <p:spPr>
           <a:xfrm>
-            <a:off x="2225891" y="4801240"/>
+            <a:off x="3439590" y="4801240"/>
             <a:ext cx="1807172" cy="318164"/>
           </a:xfrm>
           <a:prstGeom prst="rect">
@@ -10330,7 +10761,7 @@
         </p:blipFill>
         <p:spPr>
           <a:xfrm>
-            <a:off x="3325631" y="4113625"/>
+            <a:off x="3380223" y="4113625"/>
             <a:ext cx="1516170" cy="285347"/>
           </a:xfrm>
           <a:prstGeom prst="rect">
@@ -10360,8 +10791,38 @@
         </p:blipFill>
         <p:spPr>
           <a:xfrm>
-            <a:off x="6193104" y="4747739"/>
+            <a:off x="7406803" y="4747739"/>
             <a:ext cx="509380" cy="324151"/>
+          </a:xfrm>
+          <a:prstGeom prst="rect">
+            <a:avLst/>
+          </a:prstGeom>
+        </p:spPr>
+      </p:pic>
+      <p:pic>
+        <p:nvPicPr>
+          <p:cNvPr id="3" name="Picture 2">
+            <a:extLst>
+              <a:ext uri="{FF2B5EF4-FFF2-40B4-BE49-F238E27FC236}">
+                <a16:creationId xmlns:a16="http://schemas.microsoft.com/office/drawing/2014/main" id="{AA59B301-6A68-2D87-3402-0FCB75389035}"/>
+              </a:ext>
+            </a:extLst>
+          </p:cNvPr>
+          <p:cNvPicPr>
+            <a:picLocks noChangeAspect="1"/>
+          </p:cNvPicPr>
+          <p:nvPr/>
+        </p:nvPicPr>
+        <p:blipFill>
+          <a:blip r:embed="rId24"/>
+          <a:stretch>
+            <a:fillRect/>
+          </a:stretch>
+        </p:blipFill>
+        <p:spPr>
+          <a:xfrm>
+            <a:off x="8905554" y="4129819"/>
+            <a:ext cx="1303057" cy="242247"/>
           </a:xfrm>
           <a:prstGeom prst="rect">
             <a:avLst/>

</xml_diff>